<commit_message>
Fix slide 6 chart: remove empty data points that make PowerPoint repair the slide
Co-Authored-By: Claude Sonnet 5.5 <noreply@anthropic.com>
Claude-Session: https://claude.ai/code/session_01DSH8N9v9LfqAPNyYnC9CEU
</commit_message>
<xml_diff>
--- a/yuva_yodha/submission/PumpRupee_ANS_4X_Yuva_Yodha_Application.pptx
+++ b/yuva_yodha/submission/PumpRupee_ANS_4X_Yuva_Yodha_Application.pptx
@@ -198,9 +198,9 @@
           </c:marker>
           <c:cat>
             <c:multiLvlStrRef>
-              <c:f>Sheet1!$A$2:$A$14</c:f>
+              <c:f>Sheet1!$A$2:$A$8</c:f>
               <c:multiLvlStrCache>
-                <c:ptCount val="13"/>
+                <c:ptCount val="7"/>
                 <c:lvl>
                   <c:pt idx="0">
                     <c:v>10</c:v>
@@ -223,34 +223,16 @@
                   <c:pt idx="6">
                     <c:v>70</c:v>
                   </c:pt>
-                  <c:pt idx="7">
-                    <c:v>80</c:v>
-                  </c:pt>
-                  <c:pt idx="8">
-                    <c:v>90</c:v>
-                  </c:pt>
-                  <c:pt idx="9">
-                    <c:v>100</c:v>
-                  </c:pt>
-                  <c:pt idx="10">
-                    <c:v>110</c:v>
-                  </c:pt>
-                  <c:pt idx="11">
-                    <c:v>120</c:v>
-                  </c:pt>
-                  <c:pt idx="12">
-                    <c:v>130</c:v>
-                  </c:pt>
                 </c:lvl>
               </c:multiLvlStrCache>
             </c:multiLvlStrRef>
           </c:cat>
           <c:val>
             <c:numRef>
-              <c:f>Sheet1!$B$2:$B$14</c:f>
+              <c:f>Sheet1!$B$2:$B$8</c:f>
               <c:numCache>
                 <c:formatCode>General</c:formatCode>
-                <c:ptCount val="13"/>
+                <c:ptCount val="7"/>
                 <c:pt idx="0">
                   <c:v>33.1</c:v>
                 </c:pt>
@@ -271,24 +253,6 @@
                 </c:pt>
                 <c:pt idx="6">
                   <c:v>31.2</c:v>
-                </c:pt>
-                <c:pt idx="7">
-                  <c:v>30.4</c:v>
-                </c:pt>
-                <c:pt idx="8">
-                  <c:v>29.4</c:v>
-                </c:pt>
-                <c:pt idx="9">
-                  <c:v>28.2</c:v>
-                </c:pt>
-                <c:pt idx="10">
-                  <c:v>26.7</c:v>
-                </c:pt>
-                <c:pt idx="11">
-                  <c:v>25</c:v>
-                </c:pt>
-                <c:pt idx="12">
-                  <c:v>22.9</c:v>
                 </c:pt>
               </c:numCache>
             </c:numRef>
@@ -366,9 +330,9 @@
           </c:marker>
           <c:cat>
             <c:multiLvlStrRef>
-              <c:f>Sheet1!$A$2:$A$14</c:f>
+              <c:f>Sheet1!$A$2:$A$8</c:f>
               <c:multiLvlStrCache>
-                <c:ptCount val="13"/>
+                <c:ptCount val="7"/>
                 <c:lvl>
                   <c:pt idx="0">
                     <c:v>10</c:v>
@@ -391,34 +355,16 @@
                   <c:pt idx="6">
                     <c:v>70</c:v>
                   </c:pt>
-                  <c:pt idx="7">
-                    <c:v>80</c:v>
-                  </c:pt>
-                  <c:pt idx="8">
-                    <c:v>90</c:v>
-                  </c:pt>
-                  <c:pt idx="9">
-                    <c:v>100</c:v>
-                  </c:pt>
-                  <c:pt idx="10">
-                    <c:v>110</c:v>
-                  </c:pt>
-                  <c:pt idx="11">
-                    <c:v>120</c:v>
-                  </c:pt>
-                  <c:pt idx="12">
-                    <c:v>130</c:v>
-                  </c:pt>
                 </c:lvl>
               </c:multiLvlStrCache>
             </c:multiLvlStrRef>
           </c:cat>
           <c:val>
             <c:numRef>
-              <c:f>Sheet1!$C$2:$C$14</c:f>
+              <c:f>Sheet1!$C$2:$C$8</c:f>
               <c:numCache>
                 <c:formatCode>General</c:formatCode>
-                <c:ptCount val="13"/>
+                <c:ptCount val="7"/>
                 <c:pt idx="0">
                   <c:v>10.1</c:v>
                 </c:pt>
@@ -439,24 +385,6 @@
                 </c:pt>
                 <c:pt idx="6">
                   <c:v>16.1</c:v>
-                </c:pt>
-                <c:pt idx="7">
-                  <c:v>17.9</c:v>
-                </c:pt>
-                <c:pt idx="8">
-                  <c:v>20</c:v>
-                </c:pt>
-                <c:pt idx="9">
-                  <c:v>22.4</c:v>
-                </c:pt>
-                <c:pt idx="10">
-                  <c:v>25</c:v>
-                </c:pt>
-                <c:pt idx="11">
-                  <c:v>27.8</c:v>
-                </c:pt>
-                <c:pt idx="12">
-                  <c:v>30.9</c:v>
                 </c:pt>
               </c:numCache>
             </c:numRef>
@@ -534,9 +462,9 @@
           </c:marker>
           <c:cat>
             <c:multiLvlStrRef>
-              <c:f>Sheet1!$A$2:$A$14</c:f>
+              <c:f>Sheet1!$A$2:$A$8</c:f>
               <c:multiLvlStrCache>
-                <c:ptCount val="13"/>
+                <c:ptCount val="7"/>
                 <c:lvl>
                   <c:pt idx="0">
                     <c:v>10</c:v>
@@ -559,34 +487,16 @@
                   <c:pt idx="6">
                     <c:v>70</c:v>
                   </c:pt>
-                  <c:pt idx="7">
-                    <c:v>80</c:v>
-                  </c:pt>
-                  <c:pt idx="8">
-                    <c:v>90</c:v>
-                  </c:pt>
-                  <c:pt idx="9">
-                    <c:v>100</c:v>
-                  </c:pt>
-                  <c:pt idx="10">
-                    <c:v>110</c:v>
-                  </c:pt>
-                  <c:pt idx="11">
-                    <c:v>120</c:v>
-                  </c:pt>
-                  <c:pt idx="12">
-                    <c:v>130</c:v>
-                  </c:pt>
                 </c:lvl>
               </c:multiLvlStrCache>
             </c:multiLvlStrRef>
           </c:cat>
           <c:val>
             <c:numRef>
-              <c:f>Sheet1!$D$2:$D$14</c:f>
+              <c:f>Sheet1!$D$2:$D$8</c:f>
               <c:numCache>
                 <c:formatCode>General</c:formatCode>
-                <c:ptCount val="13"/>
+                <c:ptCount val="7"/>
                 <c:pt idx="0">
                   <c:v>10.6</c:v>
                 </c:pt>
@@ -607,24 +517,6 @@
                 </c:pt>
                 <c:pt idx="6">
                   <c:v>38.1</c:v>
-                </c:pt>
-                <c:pt idx="7">
-                  <c:v/>
-                </c:pt>
-                <c:pt idx="8">
-                  <c:v/>
-                </c:pt>
-                <c:pt idx="9">
-                  <c:v/>
-                </c:pt>
-                <c:pt idx="10">
-                  <c:v/>
-                </c:pt>
-                <c:pt idx="11">
-                  <c:v/>
-                </c:pt>
-                <c:pt idx="12">
-                  <c:v/>
                 </c:pt>
               </c:numCache>
             </c:numRef>
@@ -702,9 +594,9 @@
           </c:marker>
           <c:cat>
             <c:multiLvlStrRef>
-              <c:f>Sheet1!$A$2:$A$14</c:f>
+              <c:f>Sheet1!$A$2:$A$8</c:f>
               <c:multiLvlStrCache>
-                <c:ptCount val="13"/>
+                <c:ptCount val="7"/>
                 <c:lvl>
                   <c:pt idx="0">
                     <c:v>10</c:v>
@@ -727,34 +619,16 @@
                   <c:pt idx="6">
                     <c:v>70</c:v>
                   </c:pt>
-                  <c:pt idx="7">
-                    <c:v>80</c:v>
-                  </c:pt>
-                  <c:pt idx="8">
-                    <c:v>90</c:v>
-                  </c:pt>
-                  <c:pt idx="9">
-                    <c:v>100</c:v>
-                  </c:pt>
-                  <c:pt idx="10">
-                    <c:v>110</c:v>
-                  </c:pt>
-                  <c:pt idx="11">
-                    <c:v>120</c:v>
-                  </c:pt>
-                  <c:pt idx="12">
-                    <c:v>130</c:v>
-                  </c:pt>
                 </c:lvl>
               </c:multiLvlStrCache>
             </c:multiLvlStrRef>
           </c:cat>
           <c:val>
             <c:numRef>
-              <c:f>Sheet1!$E$2:$E$14</c:f>
+              <c:f>Sheet1!$E$2:$E$8</c:f>
               <c:numCache>
                 <c:formatCode>General</c:formatCode>
-                <c:ptCount val="13"/>
+                <c:ptCount val="7"/>
                 <c:pt idx="0">
                   <c:v>17.1</c:v>
                 </c:pt>
@@ -775,24 +649,6 @@
                 </c:pt>
                 <c:pt idx="6">
                   <c:v>14.7</c:v>
-                </c:pt>
-                <c:pt idx="7">
-                  <c:v>13.7</c:v>
-                </c:pt>
-                <c:pt idx="8">
-                  <c:v>12.3</c:v>
-                </c:pt>
-                <c:pt idx="9">
-                  <c:v/>
-                </c:pt>
-                <c:pt idx="10">
-                  <c:v/>
-                </c:pt>
-                <c:pt idx="11">
-                  <c:v/>
-                </c:pt>
-                <c:pt idx="12">
-                  <c:v/>
                 </c:pt>
               </c:numCache>
             </c:numRef>

</xml_diff>

<commit_message>
Deck: slide 6 chart as image + flow-inference panel; team slide without photo placeholders, with references
Co-Authored-By: Claude Sonnet 5.5 <noreply@anthropic.com>
Claude-Session: https://claude.ai/code/session_01DSH8N9v9LfqAPNyYnC9CEU
</commit_message>
<xml_diff>
--- a/yuva_yodha/submission/PumpRupee_ANS_4X_Yuva_Yodha_Application.pptx
+++ b/yuva_yodha/submission/PumpRupee_ANS_4X_Yuva_Yodha_Application.pptx
@@ -115,765 +115,6 @@
     </a:lvl9pPr>
   </p:defaultTextStyle>
 </p:presentation>
-</file>
-
-<file path=ppt/charts/chart1.xml><?xml version="1.0" encoding="utf-8"?>
-<c:chartSpace xmlns:c="http://schemas.openxmlformats.org/drawingml/2006/chart" xmlns:a="http://schemas.openxmlformats.org/drawingml/2006/main" xmlns:r="http://schemas.openxmlformats.org/officeDocument/2006/relationships">
-  <c:date1904 val="0"/>
-  <c:roundedCorners val="1"/>
-  <c:chart>
-    <c:autoTitleDeleted val="1"/>
-    <c:plotArea>
-      <c:layout/>
-      <c:lineChart>
-        <c:varyColors val="0"/>
-        <c:ser>
-          <c:idx val="0"/>
-          <c:order val="0"/>
-          <c:tx>
-            <c:strRef>
-              <c:f>Sheet1!$B$1</c:f>
-              <c:strCache>
-                <c:ptCount val="1"/>
-                <c:pt idx="0">
-                  <c:v>Pump, full speed</c:v>
-                </c:pt>
-              </c:strCache>
-            </c:strRef>
-          </c:tx>
-          <c:spPr>
-            <a:solidFill>
-              <a:srgbClr val="0E5A32"/>
-            </a:solidFill>
-            <a:ln w="31750" cap="flat">
-              <a:solidFill>
-                <a:srgbClr val="0E5A32"/>
-              </a:solidFill>
-              <a:prstDash val="solid,solid,solid,dash"/>
-              <a:round/>
-            </a:ln>
-            <a:effectLst/>
-          </c:spPr>
-          <c:invertIfNegative val="0"/>
-          <c:dLbls>
-            <c:numFmt formatCode="#,##0" sourceLinked="0"/>
-            <c:txPr>
-              <a:bodyPr/>
-              <a:lstStyle/>
-              <a:p>
-                <a:pPr>
-                  <a:defRPr b="0" i="0" strike="noStrike" sz="1200" u="none">
-                    <a:solidFill>
-                      <a:srgbClr val="000000"/>
-                    </a:solidFill>
-                    <a:latin typeface="Arial"/>
-                  </a:defRPr>
-                </a:pPr>
-              </a:p>
-            </c:txPr>
-            <c:showLegendKey val="0"/>
-            <c:showVal val="0"/>
-            <c:showCatName val="0"/>
-            <c:showSerName val="0"/>
-            <c:showPercent val="0"/>
-            <c:showBubbleSize val="0"/>
-            <c:showLeaderLines val="0"/>
-          </c:dLbls>
-          <c:marker>
-            <c:symbol val="none"/>
-            <c:size val="6"/>
-            <c:spPr>
-              <a:solidFill>
-                <a:srgbClr val="0E5A32"/>
-              </a:solidFill>
-              <a:ln w="9525" cap="flat">
-                <a:solidFill>
-                  <a:srgbClr val="0E5A32"/>
-                </a:solidFill>
-                <a:prstDash val="solid"/>
-                <a:round/>
-              </a:ln>
-              <a:effectLst/>
-            </c:spPr>
-          </c:marker>
-          <c:cat>
-            <c:multiLvlStrRef>
-              <c:f>Sheet1!$A$2:$A$8</c:f>
-              <c:multiLvlStrCache>
-                <c:ptCount val="7"/>
-                <c:lvl>
-                  <c:pt idx="0">
-                    <c:v>10</c:v>
-                  </c:pt>
-                  <c:pt idx="1">
-                    <c:v>20</c:v>
-                  </c:pt>
-                  <c:pt idx="2">
-                    <c:v>30</c:v>
-                  </c:pt>
-                  <c:pt idx="3">
-                    <c:v>40</c:v>
-                  </c:pt>
-                  <c:pt idx="4">
-                    <c:v>50</c:v>
-                  </c:pt>
-                  <c:pt idx="5">
-                    <c:v>60</c:v>
-                  </c:pt>
-                  <c:pt idx="6">
-                    <c:v>70</c:v>
-                  </c:pt>
-                </c:lvl>
-              </c:multiLvlStrCache>
-            </c:multiLvlStrRef>
-          </c:cat>
-          <c:val>
-            <c:numRef>
-              <c:f>Sheet1!$B$2:$B$8</c:f>
-              <c:numCache>
-                <c:formatCode>General</c:formatCode>
-                <c:ptCount val="7"/>
-                <c:pt idx="0">
-                  <c:v>33.1</c:v>
-                </c:pt>
-                <c:pt idx="1">
-                  <c:v>33</c:v>
-                </c:pt>
-                <c:pt idx="2">
-                  <c:v>32.8</c:v>
-                </c:pt>
-                <c:pt idx="3">
-                  <c:v>32.6</c:v>
-                </c:pt>
-                <c:pt idx="4">
-                  <c:v>32.3</c:v>
-                </c:pt>
-                <c:pt idx="5">
-                  <c:v>31.8</c:v>
-                </c:pt>
-                <c:pt idx="6">
-                  <c:v>31.2</c:v>
-                </c:pt>
-              </c:numCache>
-            </c:numRef>
-          </c:val>
-          <c:smooth val="0"/>
-        </c:ser>
-        <c:ser>
-          <c:idx val="1"/>
-          <c:order val="1"/>
-          <c:tx>
-            <c:strRef>
-              <c:f>Sheet1!$C$1</c:f>
-              <c:strCache>
-                <c:ptCount val="1"/>
-                <c:pt idx="0">
-                  <c:v>System, valve open (assumed 10 m lift)</c:v>
-                </c:pt>
-              </c:strCache>
-            </c:strRef>
-          </c:tx>
-          <c:spPr>
-            <a:solidFill>
-              <a:srgbClr val="9AA5A0"/>
-            </a:solidFill>
-            <a:ln w="31750" cap="flat">
-              <a:solidFill>
-                <a:srgbClr val="9AA5A0"/>
-              </a:solidFill>
-              <a:prstDash val="solid,solid,solid,dash"/>
-              <a:round/>
-            </a:ln>
-            <a:effectLst/>
-          </c:spPr>
-          <c:invertIfNegative val="0"/>
-          <c:dLbls>
-            <c:numFmt formatCode="#,##0" sourceLinked="0"/>
-            <c:txPr>
-              <a:bodyPr/>
-              <a:lstStyle/>
-              <a:p>
-                <a:pPr>
-                  <a:defRPr b="0" i="0" strike="noStrike" sz="1200" u="none">
-                    <a:solidFill>
-                      <a:srgbClr val="000000"/>
-                    </a:solidFill>
-                    <a:latin typeface="Arial"/>
-                  </a:defRPr>
-                </a:pPr>
-              </a:p>
-            </c:txPr>
-            <c:showLegendKey val="0"/>
-            <c:showVal val="0"/>
-            <c:showCatName val="0"/>
-            <c:showSerName val="0"/>
-            <c:showPercent val="0"/>
-            <c:showBubbleSize val="0"/>
-            <c:showLeaderLines val="0"/>
-          </c:dLbls>
-          <c:marker>
-            <c:symbol val="none"/>
-            <c:size val="6"/>
-            <c:spPr>
-              <a:solidFill>
-                <a:srgbClr val="9AA5A0"/>
-              </a:solidFill>
-              <a:ln w="9525" cap="flat">
-                <a:solidFill>
-                  <a:srgbClr val="9AA5A0"/>
-                </a:solidFill>
-                <a:prstDash val="solid"/>
-                <a:round/>
-              </a:ln>
-              <a:effectLst/>
-            </c:spPr>
-          </c:marker>
-          <c:cat>
-            <c:multiLvlStrRef>
-              <c:f>Sheet1!$A$2:$A$8</c:f>
-              <c:multiLvlStrCache>
-                <c:ptCount val="7"/>
-                <c:lvl>
-                  <c:pt idx="0">
-                    <c:v>10</c:v>
-                  </c:pt>
-                  <c:pt idx="1">
-                    <c:v>20</c:v>
-                  </c:pt>
-                  <c:pt idx="2">
-                    <c:v>30</c:v>
-                  </c:pt>
-                  <c:pt idx="3">
-                    <c:v>40</c:v>
-                  </c:pt>
-                  <c:pt idx="4">
-                    <c:v>50</c:v>
-                  </c:pt>
-                  <c:pt idx="5">
-                    <c:v>60</c:v>
-                  </c:pt>
-                  <c:pt idx="6">
-                    <c:v>70</c:v>
-                  </c:pt>
-                </c:lvl>
-              </c:multiLvlStrCache>
-            </c:multiLvlStrRef>
-          </c:cat>
-          <c:val>
-            <c:numRef>
-              <c:f>Sheet1!$C$2:$C$8</c:f>
-              <c:numCache>
-                <c:formatCode>General</c:formatCode>
-                <c:ptCount val="7"/>
-                <c:pt idx="0">
-                  <c:v>10.1</c:v>
-                </c:pt>
-                <c:pt idx="1">
-                  <c:v>10.5</c:v>
-                </c:pt>
-                <c:pt idx="2">
-                  <c:v>11.1</c:v>
-                </c:pt>
-                <c:pt idx="3">
-                  <c:v>12</c:v>
-                </c:pt>
-                <c:pt idx="4">
-                  <c:v>13.1</c:v>
-                </c:pt>
-                <c:pt idx="5">
-                  <c:v>14.5</c:v>
-                </c:pt>
-                <c:pt idx="6">
-                  <c:v>16.1</c:v>
-                </c:pt>
-              </c:numCache>
-            </c:numRef>
-          </c:val>
-          <c:smooth val="0"/>
-        </c:ser>
-        <c:ser>
-          <c:idx val="2"/>
-          <c:order val="2"/>
-          <c:tx>
-            <c:strRef>
-              <c:f>Sheet1!$D$1</c:f>
-              <c:strCache>
-                <c:ptCount val="1"/>
-                <c:pt idx="0">
-                  <c:v>System, throttled</c:v>
-                </c:pt>
-              </c:strCache>
-            </c:strRef>
-          </c:tx>
-          <c:spPr>
-            <a:solidFill>
-              <a:srgbClr val="E07B00"/>
-            </a:solidFill>
-            <a:ln w="31750" cap="flat">
-              <a:solidFill>
-                <a:srgbClr val="E07B00"/>
-              </a:solidFill>
-              <a:prstDash val="solid,solid,solid,dash"/>
-              <a:round/>
-            </a:ln>
-            <a:effectLst/>
-          </c:spPr>
-          <c:invertIfNegative val="0"/>
-          <c:dLbls>
-            <c:numFmt formatCode="#,##0" sourceLinked="0"/>
-            <c:txPr>
-              <a:bodyPr/>
-              <a:lstStyle/>
-              <a:p>
-                <a:pPr>
-                  <a:defRPr b="0" i="0" strike="noStrike" sz="1200" u="none">
-                    <a:solidFill>
-                      <a:srgbClr val="000000"/>
-                    </a:solidFill>
-                    <a:latin typeface="Arial"/>
-                  </a:defRPr>
-                </a:pPr>
-              </a:p>
-            </c:txPr>
-            <c:showLegendKey val="0"/>
-            <c:showVal val="0"/>
-            <c:showCatName val="0"/>
-            <c:showSerName val="0"/>
-            <c:showPercent val="0"/>
-            <c:showBubbleSize val="0"/>
-            <c:showLeaderLines val="0"/>
-          </c:dLbls>
-          <c:marker>
-            <c:symbol val="none"/>
-            <c:size val="6"/>
-            <c:spPr>
-              <a:solidFill>
-                <a:srgbClr val="E07B00"/>
-              </a:solidFill>
-              <a:ln w="9525" cap="flat">
-                <a:solidFill>
-                  <a:srgbClr val="E07B00"/>
-                </a:solidFill>
-                <a:prstDash val="solid"/>
-                <a:round/>
-              </a:ln>
-              <a:effectLst/>
-            </c:spPr>
-          </c:marker>
-          <c:cat>
-            <c:multiLvlStrRef>
-              <c:f>Sheet1!$A$2:$A$8</c:f>
-              <c:multiLvlStrCache>
-                <c:ptCount val="7"/>
-                <c:lvl>
-                  <c:pt idx="0">
-                    <c:v>10</c:v>
-                  </c:pt>
-                  <c:pt idx="1">
-                    <c:v>20</c:v>
-                  </c:pt>
-                  <c:pt idx="2">
-                    <c:v>30</c:v>
-                  </c:pt>
-                  <c:pt idx="3">
-                    <c:v>40</c:v>
-                  </c:pt>
-                  <c:pt idx="4">
-                    <c:v>50</c:v>
-                  </c:pt>
-                  <c:pt idx="5">
-                    <c:v>60</c:v>
-                  </c:pt>
-                  <c:pt idx="6">
-                    <c:v>70</c:v>
-                  </c:pt>
-                </c:lvl>
-              </c:multiLvlStrCache>
-            </c:multiLvlStrRef>
-          </c:cat>
-          <c:val>
-            <c:numRef>
-              <c:f>Sheet1!$D$2:$D$8</c:f>
-              <c:numCache>
-                <c:formatCode>General</c:formatCode>
-                <c:ptCount val="7"/>
-                <c:pt idx="0">
-                  <c:v>10.6</c:v>
-                </c:pt>
-                <c:pt idx="1">
-                  <c:v>12.3</c:v>
-                </c:pt>
-                <c:pt idx="2">
-                  <c:v>15.2</c:v>
-                </c:pt>
-                <c:pt idx="3">
-                  <c:v>19.2</c:v>
-                </c:pt>
-                <c:pt idx="4">
-                  <c:v>24.3</c:v>
-                </c:pt>
-                <c:pt idx="5">
-                  <c:v>30.7</c:v>
-                </c:pt>
-                <c:pt idx="6">
-                  <c:v>38.1</c:v>
-                </c:pt>
-              </c:numCache>
-            </c:numRef>
-          </c:val>
-          <c:smooth val="0"/>
-        </c:ser>
-        <c:ser>
-          <c:idx val="3"/>
-          <c:order val="3"/>
-          <c:tx>
-            <c:strRef>
-              <c:f>Sheet1!$E$1</c:f>
-              <c:strCache>
-                <c:ptCount val="1"/>
-                <c:pt idx="0">
-                  <c:v>Pump slowed by VFD (72%)</c:v>
-                </c:pt>
-              </c:strCache>
-            </c:strRef>
-          </c:tx>
-          <c:spPr>
-            <a:solidFill>
-              <a:srgbClr val="3DCD58"/>
-            </a:solidFill>
-            <a:ln w="31750" cap="flat">
-              <a:solidFill>
-                <a:srgbClr val="3DCD58"/>
-              </a:solidFill>
-              <a:prstDash val="solid,solid,solid,dash"/>
-              <a:round/>
-            </a:ln>
-            <a:effectLst/>
-          </c:spPr>
-          <c:invertIfNegative val="0"/>
-          <c:dLbls>
-            <c:numFmt formatCode="#,##0" sourceLinked="0"/>
-            <c:txPr>
-              <a:bodyPr/>
-              <a:lstStyle/>
-              <a:p>
-                <a:pPr>
-                  <a:defRPr b="0" i="0" strike="noStrike" sz="1200" u="none">
-                    <a:solidFill>
-                      <a:srgbClr val="000000"/>
-                    </a:solidFill>
-                    <a:latin typeface="Arial"/>
-                  </a:defRPr>
-                </a:pPr>
-              </a:p>
-            </c:txPr>
-            <c:showLegendKey val="0"/>
-            <c:showVal val="0"/>
-            <c:showCatName val="0"/>
-            <c:showSerName val="0"/>
-            <c:showPercent val="0"/>
-            <c:showBubbleSize val="0"/>
-            <c:showLeaderLines val="0"/>
-          </c:dLbls>
-          <c:marker>
-            <c:symbol val="none"/>
-            <c:size val="6"/>
-            <c:spPr>
-              <a:solidFill>
-                <a:srgbClr val="3DCD58"/>
-              </a:solidFill>
-              <a:ln w="9525" cap="flat">
-                <a:solidFill>
-                  <a:srgbClr val="3DCD58"/>
-                </a:solidFill>
-                <a:prstDash val="solid"/>
-                <a:round/>
-              </a:ln>
-              <a:effectLst/>
-            </c:spPr>
-          </c:marker>
-          <c:cat>
-            <c:multiLvlStrRef>
-              <c:f>Sheet1!$A$2:$A$8</c:f>
-              <c:multiLvlStrCache>
-                <c:ptCount val="7"/>
-                <c:lvl>
-                  <c:pt idx="0">
-                    <c:v>10</c:v>
-                  </c:pt>
-                  <c:pt idx="1">
-                    <c:v>20</c:v>
-                  </c:pt>
-                  <c:pt idx="2">
-                    <c:v>30</c:v>
-                  </c:pt>
-                  <c:pt idx="3">
-                    <c:v>40</c:v>
-                  </c:pt>
-                  <c:pt idx="4">
-                    <c:v>50</c:v>
-                  </c:pt>
-                  <c:pt idx="5">
-                    <c:v>60</c:v>
-                  </c:pt>
-                  <c:pt idx="6">
-                    <c:v>70</c:v>
-                  </c:pt>
-                </c:lvl>
-              </c:multiLvlStrCache>
-            </c:multiLvlStrRef>
-          </c:cat>
-          <c:val>
-            <c:numRef>
-              <c:f>Sheet1!$E$2:$E$8</c:f>
-              <c:numCache>
-                <c:formatCode>General</c:formatCode>
-                <c:ptCount val="7"/>
-                <c:pt idx="0">
-                  <c:v>17.1</c:v>
-                </c:pt>
-                <c:pt idx="1">
-                  <c:v>17</c:v>
-                </c:pt>
-                <c:pt idx="2">
-                  <c:v>16.8</c:v>
-                </c:pt>
-                <c:pt idx="3">
-                  <c:v>16.5</c:v>
-                </c:pt>
-                <c:pt idx="4">
-                  <c:v>16.1</c:v>
-                </c:pt>
-                <c:pt idx="5">
-                  <c:v>15.5</c:v>
-                </c:pt>
-                <c:pt idx="6">
-                  <c:v>14.7</c:v>
-                </c:pt>
-              </c:numCache>
-            </c:numRef>
-          </c:val>
-          <c:smooth val="0"/>
-        </c:ser>
-        <c:dLbls>
-          <c:numFmt formatCode="#,##0" sourceLinked="0"/>
-          <c:txPr>
-            <a:bodyPr/>
-            <a:lstStyle/>
-            <a:p>
-              <a:pPr>
-                <a:defRPr b="0" i="0" strike="noStrike" sz="1200" u="none">
-                  <a:solidFill>
-                    <a:srgbClr val="000000"/>
-                  </a:solidFill>
-                  <a:latin typeface="Arial"/>
-                </a:defRPr>
-              </a:pPr>
-            </a:p>
-          </c:txPr>
-          <c:showLegendKey val="0"/>
-          <c:showVal val="0"/>
-          <c:showCatName val="0"/>
-          <c:showSerName val="0"/>
-          <c:showPercent val="0"/>
-          <c:showBubbleSize val="0"/>
-          <c:showLeaderLines val="0"/>
-        </c:dLbls>
-        <c:marker val="1"/>
-        <c:axId val="2094734554"/>
-        <c:axId val="2094734552"/>
-        <c:axId val="2094734556"/>
-      </c:lineChart>
-      <c:catAx>
-        <c:axId val="2094734554"/>
-        <c:scaling>
-          <c:orientation val="minMax"/>
-        </c:scaling>
-        <c:delete val="0"/>
-        <c:axPos val="b"/>
-        <c:title>
-          <c:tx>
-            <c:rich>
-              <a:bodyPr/>
-              <a:lstStyle/>
-              <a:p>
-                <a:pPr>
-                  <a:defRPr sz="900" b="0" i="0" u="none" strike="noStrike">
-                    <a:solidFill>
-                      <a:srgbClr val="000000"/>
-                    </a:solidFill>
-                    <a:latin typeface="Arial"/>
-                  </a:defRPr>
-                </a:pPr>
-                <a:r>
-                  <a:rPr sz="900" b="0" i="0" u="none" strike="noStrike">
-                    <a:solidFill>
-                      <a:srgbClr val="000000"/>
-                    </a:solidFill>
-                    <a:latin typeface="Arial"/>
-                  </a:rPr>
-                  <a:t>Flow, m³/h</a:t>
-                </a:r>
-              </a:p>
-            </c:rich>
-          </c:tx>
-          <c:layout/>
-          <c:overlay val="0"/>
-        </c:title>
-        <c:numFmt formatCode="General" sourceLinked="1"/>
-        <c:majorTickMark val="out"/>
-        <c:minorTickMark val="none"/>
-        <c:tickLblPos val="low"/>
-        <c:spPr>
-          <a:ln w="12700" cap="flat">
-            <a:solidFill>
-              <a:srgbClr val="888888"/>
-            </a:solidFill>
-            <a:prstDash val="solid"/>
-            <a:round/>
-          </a:ln>
-        </c:spPr>
-        <c:txPr>
-          <a:bodyPr/>
-          <a:lstStyle/>
-          <a:p>
-            <a:pPr>
-              <a:defRPr sz="900" b="0" i="0" u="none" strike="noStrike">
-                <a:solidFill>
-                  <a:srgbClr val="000000"/>
-                </a:solidFill>
-                <a:latin typeface="Calibri"/>
-              </a:defRPr>
-            </a:pPr>
-            <a:endParaRPr lang="en-US"/>
-          </a:p>
-        </c:txPr>
-        <c:crossAx val="2094734552"/>
-        <c:crosses val="autoZero"/>
-        <c:auto val="1"/>
-        <c:lblAlgn val="ctr"/>
-        <c:noMultiLvlLbl val="1"/>
-      </c:catAx>
-      <c:valAx>
-        <c:axId val="2094734552"/>
-        <c:scaling>
-          <c:orientation val="minMax"/>
-          <c:max val="40"/>
-          <c:min val="0"/>
-        </c:scaling>
-        <c:delete val="0"/>
-        <c:axPos val="l"/>
-        <c:majorGridlines>
-          <c:spPr>
-            <a:ln w="6350" cap="flat">
-              <a:solidFill>
-                <a:srgbClr val="E6ECE8"/>
-              </a:solidFill>
-              <a:prstDash val="solid"/>
-              <a:round/>
-            </a:ln>
-          </c:spPr>
-        </c:majorGridlines>
-        <c:title>
-          <c:tx>
-            <c:rich>
-              <a:bodyPr/>
-              <a:lstStyle/>
-              <a:p>
-                <a:pPr>
-                  <a:defRPr sz="900" b="0" i="0" u="none" strike="noStrike">
-                    <a:solidFill>
-                      <a:srgbClr val="000000"/>
-                    </a:solidFill>
-                    <a:latin typeface="Arial"/>
-                  </a:defRPr>
-                </a:pPr>
-                <a:r>
-                  <a:rPr sz="900" b="0" i="0" u="none" strike="noStrike">
-                    <a:solidFill>
-                      <a:srgbClr val="000000"/>
-                    </a:solidFill>
-                    <a:latin typeface="Arial"/>
-                  </a:rPr>
-                  <a:t>Head, m</a:t>
-                </a:r>
-              </a:p>
-            </c:rich>
-          </c:tx>
-          <c:layout/>
-          <c:overlay val="0"/>
-        </c:title>
-        <c:numFmt formatCode="General" sourceLinked="0"/>
-        <c:majorTickMark val="out"/>
-        <c:minorTickMark val="none"/>
-        <c:tickLblPos val="nextTo"/>
-        <c:spPr>
-          <a:ln w="12700" cap="flat">
-            <a:solidFill>
-              <a:srgbClr val="888888"/>
-            </a:solidFill>
-            <a:prstDash val="solid"/>
-            <a:round/>
-          </a:ln>
-        </c:spPr>
-        <c:txPr>
-          <a:bodyPr/>
-          <a:lstStyle/>
-          <a:p>
-            <a:pPr>
-              <a:defRPr sz="900" b="0" i="0" u="none" strike="noStrike">
-                <a:solidFill>
-                  <a:srgbClr val="000000"/>
-                </a:solidFill>
-                <a:latin typeface="Calibri"/>
-              </a:defRPr>
-            </a:pPr>
-            <a:endParaRPr lang="en-US"/>
-          </a:p>
-        </c:txPr>
-        <c:crossAx val="2094734554"/>
-        <c:crosses val="autoZero"/>
-        <c:crossBetween val="between"/>
-      </c:valAx>
-      <c:spPr>
-        <a:noFill/>
-        <a:ln>
-          <a:noFill/>
-        </a:ln>
-        <a:effectLst/>
-      </c:spPr>
-    </c:plotArea>
-    <c:legend>
-      <c:legendPos val="r"/>
-      <c:overlay val="0"/>
-      <c:txPr>
-        <a:bodyPr/>
-        <a:lstStyle/>
-        <a:p>
-          <a:pPr>
-            <a:defRPr sz="900">
-              <a:latin typeface="Calibri"/>
-              <a:cs typeface="Calibri"/>
-            </a:defRPr>
-          </a:pPr>
-          <a:endParaRPr lang="en-US"/>
-        </a:p>
-      </c:txPr>
-    </c:legend>
-    <c:plotVisOnly val="1"/>
-    <c:dispBlanksAs val="span"/>
-  </c:chart>
-  <c:spPr>
-    <a:noFill/>
-    <a:ln>
-      <a:noFill/>
-    </a:ln>
-    <a:effectLst/>
-  </c:spPr>
-  <c:externalData r:id="rId1">
-    <c:autoUpdate val="0"/>
-  </c:externalData>
-</c:chartSpace>
 </file>
 
 <file path=ppt/notesMasters/notesMaster1.xml><?xml version="1.0" encoding="utf-8"?>
@@ -1447,7 +688,7 @@
           <a:p>
             <a:r>
               <a:rPr lang="en-US" dirty="0"/>
-              <a:t>Close: cheap kit, clever inference, answers in rupees. Share the live link.</a:t>
+              <a:t>Every number traces to the Grundfos readouts, the CEA factor, indicative online prices, or our own simulation scripts. Close with the key message and the live link.</a:t>
             </a:r>
             <a:endParaRPr lang="en-US" dirty="0"/>
           </a:p>
@@ -5153,12 +4394,12 @@
         </p:nvSpPr>
         <p:spPr>
           <a:xfrm>
-            <a:off x="548640" y="1371600"/>
-            <a:ext cx="2651760" cy="3520440"/>
+            <a:off x="548640" y="1280160"/>
+            <a:ext cx="2651760" cy="1783080"/>
           </a:xfrm>
           <a:prstGeom prst="roundRect">
             <a:avLst>
-              <a:gd name="adj" fmla="val 2759"/>
+              <a:gd name="adj" fmla="val 4103"/>
             </a:avLst>
           </a:prstGeom>
           <a:solidFill>
@@ -5180,722 +4421,26 @@
         </p:nvSpPr>
         <p:spPr>
           <a:xfrm>
-            <a:off x="1234440" y="1554480"/>
-            <a:ext cx="1280160" cy="1280160"/>
+            <a:off x="685800" y="1389888"/>
+            <a:ext cx="457200" cy="457200"/>
           </a:xfrm>
           <a:prstGeom prst="ellipse">
             <a:avLst/>
           </a:prstGeom>
           <a:solidFill>
-            <a:srgbClr val="E3F6E8"/>
-          </a:solidFill>
-          <a:ln w="25400">
-            <a:solidFill>
-              <a:srgbClr val="3DCD58"/>
-            </a:solidFill>
-            <a:prstDash val="solid"/>
-          </a:ln>
-        </p:spPr>
-      </p:sp>
-      <p:sp>
-        <p:nvSpPr>
-          <p:cNvPr id="6" name="Text 4"/>
-          <p:cNvSpPr txBox="1"/>
-          <p:nvPr/>
-        </p:nvSpPr>
-        <p:spPr>
-          <a:xfrm>
-            <a:off x="1234440" y="1554480"/>
-            <a:ext cx="1280160" cy="1280160"/>
-          </a:xfrm>
-          <a:prstGeom prst="rect">
-            <a:avLst/>
-          </a:prstGeom>
-          <a:noFill/>
-          <a:ln/>
-        </p:spPr>
-        <p:txBody>
-          <a:bodyPr wrap="square" lIns="0" tIns="0" rIns="0" bIns="0" rtlCol="0" anchor="ctr"/>
-          <a:lstStyle/>
-          <a:p>
-            <a:pPr algn="ctr" indent="0" marL="0">
-              <a:buNone/>
-            </a:pPr>
-            <a:r>
-              <a:rPr lang="en-US" sz="1200" dirty="0">
-                <a:solidFill>
-                  <a:srgbClr val="55655D"/>
-                </a:solidFill>
-                <a:latin typeface="Calibri" pitchFamily="34" charset="0"/>
-                <a:ea typeface="Calibri" pitchFamily="34" charset="-122"/>
-                <a:cs typeface="Calibri" pitchFamily="34" charset="-120"/>
-              </a:rPr>
-              <a:t>Insert</a:t>
-            </a:r>
-            <a:endParaRPr lang="en-US" sz="1200" dirty="0"/>
-          </a:p>
-          <a:p>
-            <a:pPr algn="ctr" indent="0" marL="0">
-              <a:buNone/>
-            </a:pPr>
-            <a:r>
-              <a:rPr lang="en-US" sz="1200" dirty="0">
-                <a:solidFill>
-                  <a:srgbClr val="55655D"/>
-                </a:solidFill>
-                <a:latin typeface="Calibri" pitchFamily="34" charset="0"/>
-                <a:ea typeface="Calibri" pitchFamily="34" charset="-122"/>
-                <a:cs typeface="Calibri" pitchFamily="34" charset="-120"/>
-              </a:rPr>
-              <a:t>photo</a:t>
-            </a:r>
-            <a:endParaRPr lang="en-US" sz="1200" dirty="0"/>
-          </a:p>
-        </p:txBody>
-      </p:sp>
-      <p:sp>
-        <p:nvSpPr>
-          <p:cNvPr id="7" name="Text 5"/>
-          <p:cNvSpPr txBox="1"/>
-          <p:nvPr/>
-        </p:nvSpPr>
-        <p:spPr>
-          <a:xfrm>
-            <a:off x="685800" y="2971800"/>
-            <a:ext cx="2377440" cy="1874520"/>
-          </a:xfrm>
-          <a:prstGeom prst="rect">
-            <a:avLst/>
-          </a:prstGeom>
-          <a:noFill/>
-          <a:ln/>
-        </p:spPr>
-        <p:txBody>
-          <a:bodyPr wrap="square" lIns="0" tIns="0" rIns="0" bIns="0" rtlCol="0" anchor="t"/>
-          <a:lstStyle/>
-          <a:p>
-            <a:pPr algn="ctr" indent="0" marL="0">
-              <a:spcAft>
-                <a:spcPts val="300"/>
-              </a:spcAft>
-              <a:buNone/>
-            </a:pPr>
-            <a:r>
-              <a:rPr lang="en-US" sz="1800" b="1" dirty="0">
-                <a:solidFill>
-                  <a:srgbClr val="16261F"/>
-                </a:solidFill>
-                <a:latin typeface="Calibri" pitchFamily="34" charset="0"/>
-                <a:ea typeface="Calibri" pitchFamily="34" charset="-122"/>
-                <a:cs typeface="Calibri" pitchFamily="34" charset="-120"/>
-              </a:rPr>
-              <a:t>Akshaya V G</a:t>
-            </a:r>
-            <a:endParaRPr lang="en-US" sz="1800" dirty="0"/>
-          </a:p>
-          <a:p>
-            <a:pPr algn="ctr" indent="0" marL="0">
-              <a:spcAft>
-                <a:spcPts val="600"/>
-              </a:spcAft>
-              <a:buNone/>
-            </a:pPr>
-            <a:r>
-              <a:rPr lang="en-US" sz="1300" b="1" dirty="0">
-                <a:solidFill>
-                  <a:srgbClr val="0E5A32"/>
-                </a:solidFill>
-                <a:latin typeface="Calibri" pitchFamily="34" charset="0"/>
-                <a:ea typeface="Calibri" pitchFamily="34" charset="-122"/>
-                <a:cs typeface="Calibri" pitchFamily="34" charset="-120"/>
-              </a:rPr>
-              <a:t>Team Lead &amp; Software/Dashboard</a:t>
-            </a:r>
-            <a:endParaRPr lang="en-US" sz="1800" dirty="0"/>
-          </a:p>
-          <a:p>
-            <a:pPr algn="ctr" indent="0" marL="0">
-              <a:buNone/>
-            </a:pPr>
-            <a:r>
-              <a:rPr lang="en-US" sz="1200" dirty="0">
-                <a:solidFill>
-                  <a:srgbClr val="55655D"/>
-                </a:solidFill>
-                <a:latin typeface="Calibri" pitchFamily="34" charset="0"/>
-                <a:ea typeface="Calibri" pitchFamily="34" charset="-122"/>
-                <a:cs typeface="Calibri" pitchFamily="34" charset="-120"/>
-              </a:rPr>
-              <a:t>Data pipeline and the PumpRupee web dashboard</a:t>
-            </a:r>
-            <a:endParaRPr lang="en-US" sz="1800" dirty="0"/>
-          </a:p>
-        </p:txBody>
-      </p:sp>
-      <p:sp>
-        <p:nvSpPr>
-          <p:cNvPr id="8" name="Shape 6"/>
-          <p:cNvSpPr/>
-          <p:nvPr/>
-        </p:nvSpPr>
-        <p:spPr>
-          <a:xfrm>
-            <a:off x="3362249" y="1371600"/>
-            <a:ext cx="2651760" cy="3520440"/>
-          </a:xfrm>
-          <a:prstGeom prst="roundRect">
-            <a:avLst>
-              <a:gd name="adj" fmla="val 2759"/>
-            </a:avLst>
-          </a:prstGeom>
-          <a:solidFill>
-            <a:srgbClr val="FFFFFF"/>
+            <a:srgbClr val="0E5A32"/>
           </a:solidFill>
           <a:ln w="12700">
             <a:solidFill>
-              <a:srgbClr val="D3DFD7"/>
-            </a:solidFill>
-            <a:prstDash val="solid"/>
-          </a:ln>
-        </p:spPr>
-      </p:sp>
-      <p:sp>
-        <p:nvSpPr>
-          <p:cNvPr id="9" name="Shape 7"/>
-          <p:cNvSpPr/>
-          <p:nvPr/>
-        </p:nvSpPr>
-        <p:spPr>
-          <a:xfrm>
-            <a:off x="4048049" y="1554480"/>
-            <a:ext cx="1280160" cy="1280160"/>
-          </a:xfrm>
-          <a:prstGeom prst="ellipse">
-            <a:avLst/>
-          </a:prstGeom>
-          <a:solidFill>
-            <a:srgbClr val="E3F6E8"/>
-          </a:solidFill>
-          <a:ln w="25400">
-            <a:solidFill>
-              <a:srgbClr val="3DCD58"/>
-            </a:solidFill>
-            <a:prstDash val="solid"/>
-          </a:ln>
-        </p:spPr>
-      </p:sp>
-      <p:sp>
-        <p:nvSpPr>
-          <p:cNvPr id="10" name="Text 8"/>
-          <p:cNvSpPr txBox="1"/>
-          <p:nvPr/>
-        </p:nvSpPr>
-        <p:spPr>
-          <a:xfrm>
-            <a:off x="4048049" y="1554480"/>
-            <a:ext cx="1280160" cy="1280160"/>
-          </a:xfrm>
-          <a:prstGeom prst="rect">
-            <a:avLst/>
-          </a:prstGeom>
-          <a:noFill/>
-          <a:ln/>
-        </p:spPr>
-        <p:txBody>
-          <a:bodyPr wrap="square" lIns="0" tIns="0" rIns="0" bIns="0" rtlCol="0" anchor="ctr"/>
-          <a:lstStyle/>
-          <a:p>
-            <a:pPr algn="ctr" indent="0" marL="0">
-              <a:buNone/>
-            </a:pPr>
-            <a:r>
-              <a:rPr lang="en-US" sz="1200" dirty="0">
-                <a:solidFill>
-                  <a:srgbClr val="55655D"/>
-                </a:solidFill>
-                <a:latin typeface="Calibri" pitchFamily="34" charset="0"/>
-                <a:ea typeface="Calibri" pitchFamily="34" charset="-122"/>
-                <a:cs typeface="Calibri" pitchFamily="34" charset="-120"/>
-              </a:rPr>
-              <a:t>Insert</a:t>
-            </a:r>
-            <a:endParaRPr lang="en-US" sz="1200" dirty="0"/>
-          </a:p>
-          <a:p>
-            <a:pPr algn="ctr" indent="0" marL="0">
-              <a:buNone/>
-            </a:pPr>
-            <a:r>
-              <a:rPr lang="en-US" sz="1200" dirty="0">
-                <a:solidFill>
-                  <a:srgbClr val="55655D"/>
-                </a:solidFill>
-                <a:latin typeface="Calibri" pitchFamily="34" charset="0"/>
-                <a:ea typeface="Calibri" pitchFamily="34" charset="-122"/>
-                <a:cs typeface="Calibri" pitchFamily="34" charset="-120"/>
-              </a:rPr>
-              <a:t>photo</a:t>
-            </a:r>
-            <a:endParaRPr lang="en-US" sz="1200" dirty="0"/>
-          </a:p>
-        </p:txBody>
-      </p:sp>
-      <p:sp>
-        <p:nvSpPr>
-          <p:cNvPr id="11" name="Text 9"/>
-          <p:cNvSpPr txBox="1"/>
-          <p:nvPr/>
-        </p:nvSpPr>
-        <p:spPr>
-          <a:xfrm>
-            <a:off x="3499409" y="2971800"/>
-            <a:ext cx="2377440" cy="1874520"/>
-          </a:xfrm>
-          <a:prstGeom prst="rect">
-            <a:avLst/>
-          </a:prstGeom>
-          <a:noFill/>
-          <a:ln/>
-        </p:spPr>
-        <p:txBody>
-          <a:bodyPr wrap="square" lIns="0" tIns="0" rIns="0" bIns="0" rtlCol="0" anchor="t"/>
-          <a:lstStyle/>
-          <a:p>
-            <a:pPr algn="ctr" indent="0" marL="0">
-              <a:spcAft>
-                <a:spcPts val="300"/>
-              </a:spcAft>
-              <a:buNone/>
-            </a:pPr>
-            <a:r>
-              <a:rPr lang="en-US" sz="1800" b="1" dirty="0">
-                <a:solidFill>
-                  <a:srgbClr val="16261F"/>
-                </a:solidFill>
-                <a:latin typeface="Calibri" pitchFamily="34" charset="0"/>
-                <a:ea typeface="Calibri" pitchFamily="34" charset="-122"/>
-                <a:cs typeface="Calibri" pitchFamily="34" charset="-120"/>
-              </a:rPr>
-              <a:t>Adithyaa J</a:t>
-            </a:r>
-            <a:endParaRPr lang="en-US" sz="1800" dirty="0"/>
-          </a:p>
-          <a:p>
-            <a:pPr algn="ctr" indent="0" marL="0">
-              <a:spcAft>
-                <a:spcPts val="600"/>
-              </a:spcAft>
-              <a:buNone/>
-            </a:pPr>
-            <a:r>
-              <a:rPr lang="en-US" sz="1300" b="1" dirty="0">
-                <a:solidFill>
-                  <a:srgbClr val="0E5A32"/>
-                </a:solidFill>
-                <a:latin typeface="Calibri" pitchFamily="34" charset="0"/>
-                <a:ea typeface="Calibri" pitchFamily="34" charset="-122"/>
-                <a:cs typeface="Calibri" pitchFamily="34" charset="-120"/>
-              </a:rPr>
-              <a:t>Embedded Hardware</a:t>
-            </a:r>
-            <a:endParaRPr lang="en-US" sz="1800" dirty="0"/>
-          </a:p>
-          <a:p>
-            <a:pPr algn="ctr" indent="0" marL="0">
-              <a:buNone/>
-            </a:pPr>
-            <a:r>
-              <a:rPr lang="en-US" sz="1200" dirty="0">
-                <a:solidFill>
-                  <a:srgbClr val="55655D"/>
-                </a:solidFill>
-                <a:latin typeface="Calibri" pitchFamily="34" charset="0"/>
-                <a:ea typeface="Calibri" pitchFamily="34" charset="-122"/>
-                <a:cs typeface="Calibri" pitchFamily="34" charset="-120"/>
-              </a:rPr>
-              <a:t>ESP32 logger, power clamp and pressure-sensor integration</a:t>
-            </a:r>
-            <a:endParaRPr lang="en-US" sz="1800" dirty="0"/>
-          </a:p>
-        </p:txBody>
-      </p:sp>
-      <p:sp>
-        <p:nvSpPr>
-          <p:cNvPr id="12" name="Shape 10"/>
-          <p:cNvSpPr/>
-          <p:nvPr/>
-        </p:nvSpPr>
-        <p:spPr>
-          <a:xfrm>
-            <a:off x="6175858" y="1371600"/>
-            <a:ext cx="2651760" cy="3520440"/>
-          </a:xfrm>
-          <a:prstGeom prst="roundRect">
-            <a:avLst>
-              <a:gd name="adj" fmla="val 2759"/>
-            </a:avLst>
-          </a:prstGeom>
-          <a:solidFill>
-            <a:srgbClr val="FFFFFF"/>
-          </a:solidFill>
-          <a:ln w="12700">
-            <a:solidFill>
-              <a:srgbClr val="D3DFD7"/>
-            </a:solidFill>
-            <a:prstDash val="solid"/>
-          </a:ln>
-        </p:spPr>
-      </p:sp>
-      <p:sp>
-        <p:nvSpPr>
-          <p:cNvPr id="13" name="Shape 11"/>
-          <p:cNvSpPr/>
-          <p:nvPr/>
-        </p:nvSpPr>
-        <p:spPr>
-          <a:xfrm>
-            <a:off x="6861658" y="1554480"/>
-            <a:ext cx="1280160" cy="1280160"/>
-          </a:xfrm>
-          <a:prstGeom prst="ellipse">
-            <a:avLst/>
-          </a:prstGeom>
-          <a:solidFill>
-            <a:srgbClr val="E3F6E8"/>
-          </a:solidFill>
-          <a:ln w="25400">
-            <a:solidFill>
-              <a:srgbClr val="3DCD58"/>
-            </a:solidFill>
-            <a:prstDash val="solid"/>
-          </a:ln>
-        </p:spPr>
-      </p:sp>
-      <p:sp>
-        <p:nvSpPr>
-          <p:cNvPr id="14" name="Text 12"/>
-          <p:cNvSpPr txBox="1"/>
-          <p:nvPr/>
-        </p:nvSpPr>
-        <p:spPr>
-          <a:xfrm>
-            <a:off x="6861658" y="1554480"/>
-            <a:ext cx="1280160" cy="1280160"/>
-          </a:xfrm>
-          <a:prstGeom prst="rect">
-            <a:avLst/>
-          </a:prstGeom>
-          <a:noFill/>
-          <a:ln/>
-        </p:spPr>
-        <p:txBody>
-          <a:bodyPr wrap="square" lIns="0" tIns="0" rIns="0" bIns="0" rtlCol="0" anchor="ctr"/>
-          <a:lstStyle/>
-          <a:p>
-            <a:pPr algn="ctr" indent="0" marL="0">
-              <a:buNone/>
-            </a:pPr>
-            <a:r>
-              <a:rPr lang="en-US" sz="1200" dirty="0">
-                <a:solidFill>
-                  <a:srgbClr val="55655D"/>
-                </a:solidFill>
-                <a:latin typeface="Calibri" pitchFamily="34" charset="0"/>
-                <a:ea typeface="Calibri" pitchFamily="34" charset="-122"/>
-                <a:cs typeface="Calibri" pitchFamily="34" charset="-120"/>
-              </a:rPr>
-              <a:t>Insert</a:t>
-            </a:r>
-            <a:endParaRPr lang="en-US" sz="1200" dirty="0"/>
-          </a:p>
-          <a:p>
-            <a:pPr algn="ctr" indent="0" marL="0">
-              <a:buNone/>
-            </a:pPr>
-            <a:r>
-              <a:rPr lang="en-US" sz="1200" dirty="0">
-                <a:solidFill>
-                  <a:srgbClr val="55655D"/>
-                </a:solidFill>
-                <a:latin typeface="Calibri" pitchFamily="34" charset="0"/>
-                <a:ea typeface="Calibri" pitchFamily="34" charset="-122"/>
-                <a:cs typeface="Calibri" pitchFamily="34" charset="-120"/>
-              </a:rPr>
-              <a:t>photo</a:t>
-            </a:r>
-            <a:endParaRPr lang="en-US" sz="1200" dirty="0"/>
-          </a:p>
-        </p:txBody>
-      </p:sp>
-      <p:sp>
-        <p:nvSpPr>
-          <p:cNvPr id="15" name="Text 13"/>
-          <p:cNvSpPr txBox="1"/>
-          <p:nvPr/>
-        </p:nvSpPr>
-        <p:spPr>
-          <a:xfrm>
-            <a:off x="6313018" y="2971800"/>
-            <a:ext cx="2377440" cy="1874520"/>
-          </a:xfrm>
-          <a:prstGeom prst="rect">
-            <a:avLst/>
-          </a:prstGeom>
-          <a:noFill/>
-          <a:ln/>
-        </p:spPr>
-        <p:txBody>
-          <a:bodyPr wrap="square" lIns="0" tIns="0" rIns="0" bIns="0" rtlCol="0" anchor="t"/>
-          <a:lstStyle/>
-          <a:p>
-            <a:pPr algn="ctr" indent="0" marL="0">
-              <a:spcAft>
-                <a:spcPts val="300"/>
-              </a:spcAft>
-              <a:buNone/>
-            </a:pPr>
-            <a:r>
-              <a:rPr lang="en-US" sz="1800" b="1" dirty="0">
-                <a:solidFill>
-                  <a:srgbClr val="16261F"/>
-                </a:solidFill>
-                <a:latin typeface="Calibri" pitchFamily="34" charset="0"/>
-                <a:ea typeface="Calibri" pitchFamily="34" charset="-122"/>
-                <a:cs typeface="Calibri" pitchFamily="34" charset="-120"/>
-              </a:rPr>
-              <a:t>Nikilaesh B</a:t>
-            </a:r>
-            <a:endParaRPr lang="en-US" sz="1800" dirty="0"/>
-          </a:p>
-          <a:p>
-            <a:pPr algn="ctr" indent="0" marL="0">
-              <a:spcAft>
-                <a:spcPts val="600"/>
-              </a:spcAft>
-              <a:buNone/>
-            </a:pPr>
-            <a:r>
-              <a:rPr lang="en-US" sz="1300" b="1" dirty="0">
-                <a:solidFill>
-                  <a:srgbClr val="0E5A32"/>
-                </a:solidFill>
-                <a:latin typeface="Calibri" pitchFamily="34" charset="0"/>
-                <a:ea typeface="Calibri" pitchFamily="34" charset="-122"/>
-                <a:cs typeface="Calibri" pitchFamily="34" charset="-120"/>
-              </a:rPr>
-              <a:t>Energy Analytics</a:t>
-            </a:r>
-            <a:endParaRPr lang="en-US" sz="1800" dirty="0"/>
-          </a:p>
-          <a:p>
-            <a:pPr algn="ctr" indent="0" marL="0">
-              <a:buNone/>
-            </a:pPr>
-            <a:r>
-              <a:rPr lang="en-US" sz="1200" dirty="0">
-                <a:solidFill>
-                  <a:srgbClr val="55655D"/>
-                </a:solidFill>
-                <a:latin typeface="Calibri" pitchFamily="34" charset="0"/>
-                <a:ea typeface="Calibri" pitchFamily="34" charset="-122"/>
-                <a:cs typeface="Calibri" pitchFamily="34" charset="-120"/>
-              </a:rPr>
-              <a:t>Pump hydraulics model, Shapley waste split and VFD payback logic</a:t>
-            </a:r>
-            <a:endParaRPr lang="en-US" sz="1800" dirty="0"/>
-          </a:p>
-        </p:txBody>
-      </p:sp>
-      <p:sp>
-        <p:nvSpPr>
-          <p:cNvPr id="16" name="Shape 14"/>
-          <p:cNvSpPr/>
-          <p:nvPr/>
-        </p:nvSpPr>
-        <p:spPr>
-          <a:xfrm>
-            <a:off x="8989466" y="1371600"/>
-            <a:ext cx="2651760" cy="3520440"/>
-          </a:xfrm>
-          <a:prstGeom prst="roundRect">
-            <a:avLst>
-              <a:gd name="adj" fmla="val 2759"/>
-            </a:avLst>
-          </a:prstGeom>
-          <a:solidFill>
-            <a:srgbClr val="FFFFFF"/>
-          </a:solidFill>
-          <a:ln w="12700">
-            <a:solidFill>
-              <a:srgbClr val="D3DFD7"/>
-            </a:solidFill>
-            <a:prstDash val="solid"/>
-          </a:ln>
-        </p:spPr>
-      </p:sp>
-      <p:sp>
-        <p:nvSpPr>
-          <p:cNvPr id="17" name="Shape 15"/>
-          <p:cNvSpPr/>
-          <p:nvPr/>
-        </p:nvSpPr>
-        <p:spPr>
-          <a:xfrm>
-            <a:off x="9675266" y="1554480"/>
-            <a:ext cx="1280160" cy="1280160"/>
-          </a:xfrm>
-          <a:prstGeom prst="ellipse">
-            <a:avLst/>
-          </a:prstGeom>
-          <a:solidFill>
-            <a:srgbClr val="E3F6E8"/>
-          </a:solidFill>
-          <a:ln w="25400">
-            <a:solidFill>
-              <a:srgbClr val="3DCD58"/>
-            </a:solidFill>
-            <a:prstDash val="solid"/>
-          </a:ln>
-        </p:spPr>
-      </p:sp>
-      <p:sp>
-        <p:nvSpPr>
-          <p:cNvPr id="18" name="Text 16"/>
-          <p:cNvSpPr txBox="1"/>
-          <p:nvPr/>
-        </p:nvSpPr>
-        <p:spPr>
-          <a:xfrm>
-            <a:off x="9675266" y="1554480"/>
-            <a:ext cx="1280160" cy="1280160"/>
-          </a:xfrm>
-          <a:prstGeom prst="rect">
-            <a:avLst/>
-          </a:prstGeom>
-          <a:noFill/>
-          <a:ln/>
-        </p:spPr>
-        <p:txBody>
-          <a:bodyPr wrap="square" lIns="0" tIns="0" rIns="0" bIns="0" rtlCol="0" anchor="ctr"/>
-          <a:lstStyle/>
-          <a:p>
-            <a:pPr algn="ctr" indent="0" marL="0">
-              <a:buNone/>
-            </a:pPr>
-            <a:r>
-              <a:rPr lang="en-US" sz="1200" dirty="0">
-                <a:solidFill>
-                  <a:srgbClr val="55655D"/>
-                </a:solidFill>
-                <a:latin typeface="Calibri" pitchFamily="34" charset="0"/>
-                <a:ea typeface="Calibri" pitchFamily="34" charset="-122"/>
-                <a:cs typeface="Calibri" pitchFamily="34" charset="-120"/>
-              </a:rPr>
-              <a:t>Insert</a:t>
-            </a:r>
-            <a:endParaRPr lang="en-US" sz="1200" dirty="0"/>
-          </a:p>
-          <a:p>
-            <a:pPr algn="ctr" indent="0" marL="0">
-              <a:buNone/>
-            </a:pPr>
-            <a:r>
-              <a:rPr lang="en-US" sz="1200" dirty="0">
-                <a:solidFill>
-                  <a:srgbClr val="55655D"/>
-                </a:solidFill>
-                <a:latin typeface="Calibri" pitchFamily="34" charset="0"/>
-                <a:ea typeface="Calibri" pitchFamily="34" charset="-122"/>
-                <a:cs typeface="Calibri" pitchFamily="34" charset="-120"/>
-              </a:rPr>
-              <a:t>photo</a:t>
-            </a:r>
-            <a:endParaRPr lang="en-US" sz="1200" dirty="0"/>
-          </a:p>
-        </p:txBody>
-      </p:sp>
-      <p:sp>
-        <p:nvSpPr>
-          <p:cNvPr id="19" name="Text 17"/>
-          <p:cNvSpPr txBox="1"/>
-          <p:nvPr/>
-        </p:nvSpPr>
-        <p:spPr>
-          <a:xfrm>
-            <a:off x="9126626" y="2971800"/>
-            <a:ext cx="2377440" cy="1874520"/>
-          </a:xfrm>
-          <a:prstGeom prst="rect">
-            <a:avLst/>
-          </a:prstGeom>
-          <a:noFill/>
-          <a:ln/>
-        </p:spPr>
-        <p:txBody>
-          <a:bodyPr wrap="square" lIns="0" tIns="0" rIns="0" bIns="0" rtlCol="0" anchor="t"/>
-          <a:lstStyle/>
-          <a:p>
-            <a:pPr algn="ctr" indent="0" marL="0">
-              <a:spcAft>
-                <a:spcPts val="300"/>
-              </a:spcAft>
-              <a:buNone/>
-            </a:pPr>
-            <a:r>
-              <a:rPr lang="en-US" sz="1800" b="1" dirty="0">
-                <a:solidFill>
-                  <a:srgbClr val="16261F"/>
-                </a:solidFill>
-                <a:latin typeface="Calibri" pitchFamily="34" charset="0"/>
-                <a:ea typeface="Calibri" pitchFamily="34" charset="-122"/>
-                <a:cs typeface="Calibri" pitchFamily="34" charset="-120"/>
-              </a:rPr>
-              <a:t>Siva Subramaniam S</a:t>
-            </a:r>
-            <a:endParaRPr lang="en-US" sz="1800" dirty="0"/>
-          </a:p>
-          <a:p>
-            <a:pPr algn="ctr" indent="0" marL="0">
-              <a:spcAft>
-                <a:spcPts val="600"/>
-              </a:spcAft>
-              <a:buNone/>
-            </a:pPr>
-            <a:r>
-              <a:rPr lang="en-US" sz="1300" b="1" dirty="0">
-                <a:solidFill>
-                  <a:srgbClr val="0E5A32"/>
-                </a:solidFill>
-                <a:latin typeface="Calibri" pitchFamily="34" charset="0"/>
-                <a:ea typeface="Calibri" pitchFamily="34" charset="-122"/>
-                <a:cs typeface="Calibri" pitchFamily="34" charset="-120"/>
-              </a:rPr>
-              <a:t>Simulation &amp; Validation</a:t>
-            </a:r>
-            <a:endParaRPr lang="en-US" sz="1800" dirty="0"/>
-          </a:p>
-          <a:p>
-            <a:pPr algn="ctr" indent="0" marL="0">
-              <a:buNone/>
-            </a:pPr>
-            <a:r>
-              <a:rPr lang="en-US" sz="1200" dirty="0">
-                <a:solidFill>
-                  <a:srgbClr val="55655D"/>
-                </a:solidFill>
-                <a:latin typeface="Calibri" pitchFamily="34" charset="0"/>
-                <a:ea typeface="Calibri" pitchFamily="34" charset="-122"/>
-                <a:cs typeface="Calibri" pitchFamily="34" charset="-120"/>
-              </a:rPr>
-              <a:t>Pump-curve simulation, CUSUM wear-drift testing, pilot and roadmap planning</a:t>
-            </a:r>
-            <a:endParaRPr lang="en-US" sz="1800" dirty="0"/>
-          </a:p>
-        </p:txBody>
+              <a:srgbClr val="0E5A32"/>
+            </a:solidFill>
+            <a:prstDash val="solid"/>
+          </a:ln>
+        </p:spPr>
       </p:sp>
       <p:pic>
         <p:nvPicPr>
-          <p:cNvPr id="20" name="Image 0" descr="preencoded.png">    </p:cNvPr>
+          <p:cNvPr id="6" name="Image 0" descr="preencoded.png">    </p:cNvPr>
           <p:cNvPicPr>
             <a:picLocks noChangeAspect="1"/>
           </p:cNvPicPr>
@@ -5909,8 +4454,8 @@
         </p:blipFill>
         <p:spPr>
           <a:xfrm>
-            <a:off x="548640" y="5120640"/>
-            <a:ext cx="1005840" cy="1005840"/>
+            <a:off x="795528" y="1499616"/>
+            <a:ext cx="237744" cy="237744"/>
           </a:xfrm>
           <a:prstGeom prst="rect">
             <a:avLst/>
@@ -5919,14 +4464,70 @@
       </p:pic>
       <p:sp>
         <p:nvSpPr>
-          <p:cNvPr id="21" name="Text 18"/>
-          <p:cNvSpPr txBox="1"/>
-          <p:nvPr/>
-        </p:nvSpPr>
-        <p:spPr>
-          <a:xfrm>
-            <a:off x="1691640" y="5193792"/>
-            <a:ext cx="3840480" cy="1005840"/>
+          <p:cNvPr id="7" name="Text 4"/>
+          <p:cNvSpPr txBox="1"/>
+          <p:nvPr/>
+        </p:nvSpPr>
+        <p:spPr>
+          <a:xfrm>
+            <a:off x="1234440" y="1371600"/>
+            <a:ext cx="1874520" cy="548640"/>
+          </a:xfrm>
+          <a:prstGeom prst="rect">
+            <a:avLst/>
+          </a:prstGeom>
+          <a:noFill/>
+          <a:ln/>
+        </p:spPr>
+        <p:txBody>
+          <a:bodyPr wrap="square" lIns="0" tIns="0" rIns="0" bIns="0" rtlCol="0" anchor="ctr"/>
+          <a:lstStyle/>
+          <a:p>
+            <a:pPr indent="0" marL="0">
+              <a:buNone/>
+            </a:pPr>
+            <a:r>
+              <a:rPr lang="en-US" sz="1500" b="1" dirty="0">
+                <a:solidFill>
+                  <a:srgbClr val="16261F"/>
+                </a:solidFill>
+                <a:latin typeface="Calibri" pitchFamily="34" charset="0"/>
+                <a:ea typeface="Calibri" pitchFamily="34" charset="-122"/>
+                <a:cs typeface="Calibri" pitchFamily="34" charset="-120"/>
+              </a:rPr>
+              <a:t>Akshaya V G</a:t>
+            </a:r>
+            <a:endParaRPr lang="en-US" sz="1500" dirty="0"/>
+          </a:p>
+          <a:p>
+            <a:pPr indent="0" marL="0">
+              <a:buNone/>
+            </a:pPr>
+            <a:r>
+              <a:rPr lang="en-US" sz="1100" b="1" dirty="0">
+                <a:solidFill>
+                  <a:srgbClr val="0E5A32"/>
+                </a:solidFill>
+                <a:latin typeface="Calibri" pitchFamily="34" charset="0"/>
+                <a:ea typeface="Calibri" pitchFamily="34" charset="-122"/>
+                <a:cs typeface="Calibri" pitchFamily="34" charset="-120"/>
+              </a:rPr>
+              <a:t>Team Lead &amp; Software/Dashboard</a:t>
+            </a:r>
+            <a:endParaRPr lang="en-US" sz="1500" dirty="0"/>
+          </a:p>
+        </p:txBody>
+      </p:sp>
+      <p:sp>
+        <p:nvSpPr>
+          <p:cNvPr id="8" name="Text 5"/>
+          <p:cNvSpPr txBox="1"/>
+          <p:nvPr/>
+        </p:nvSpPr>
+        <p:spPr>
+          <a:xfrm>
+            <a:off x="685800" y="2011680"/>
+            <a:ext cx="2377440" cy="1005840"/>
           </a:xfrm>
           <a:prstGeom prst="rect">
             <a:avLst/>
@@ -5942,6 +4543,860 @@
               <a:buNone/>
             </a:pPr>
             <a:r>
+              <a:rPr lang="en-US" sz="1150" dirty="0">
+                <a:solidFill>
+                  <a:srgbClr val="55655D"/>
+                </a:solidFill>
+                <a:latin typeface="Calibri" pitchFamily="34" charset="0"/>
+                <a:ea typeface="Calibri" pitchFamily="34" charset="-122"/>
+                <a:cs typeface="Calibri" pitchFamily="34" charset="-120"/>
+              </a:rPr>
+              <a:t>Data pipeline and the PumpRupee web dashboard</a:t>
+            </a:r>
+            <a:endParaRPr lang="en-US" sz="1150" dirty="0"/>
+          </a:p>
+        </p:txBody>
+      </p:sp>
+      <p:sp>
+        <p:nvSpPr>
+          <p:cNvPr id="9" name="Shape 6"/>
+          <p:cNvSpPr/>
+          <p:nvPr/>
+        </p:nvSpPr>
+        <p:spPr>
+          <a:xfrm>
+            <a:off x="3362249" y="1280160"/>
+            <a:ext cx="2651760" cy="1783080"/>
+          </a:xfrm>
+          <a:prstGeom prst="roundRect">
+            <a:avLst>
+              <a:gd name="adj" fmla="val 4103"/>
+            </a:avLst>
+          </a:prstGeom>
+          <a:solidFill>
+            <a:srgbClr val="FFFFFF"/>
+          </a:solidFill>
+          <a:ln w="12700">
+            <a:solidFill>
+              <a:srgbClr val="D3DFD7"/>
+            </a:solidFill>
+            <a:prstDash val="solid"/>
+          </a:ln>
+        </p:spPr>
+      </p:sp>
+      <p:sp>
+        <p:nvSpPr>
+          <p:cNvPr id="10" name="Shape 7"/>
+          <p:cNvSpPr/>
+          <p:nvPr/>
+        </p:nvSpPr>
+        <p:spPr>
+          <a:xfrm>
+            <a:off x="3499409" y="1389888"/>
+            <a:ext cx="457200" cy="457200"/>
+          </a:xfrm>
+          <a:prstGeom prst="ellipse">
+            <a:avLst/>
+          </a:prstGeom>
+          <a:solidFill>
+            <a:srgbClr val="0E5A32"/>
+          </a:solidFill>
+          <a:ln w="12700">
+            <a:solidFill>
+              <a:srgbClr val="0E5A32"/>
+            </a:solidFill>
+            <a:prstDash val="solid"/>
+          </a:ln>
+        </p:spPr>
+      </p:sp>
+      <p:pic>
+        <p:nvPicPr>
+          <p:cNvPr id="11" name="Image 1" descr="preencoded.png">    </p:cNvPr>
+          <p:cNvPicPr>
+            <a:picLocks noChangeAspect="1"/>
+          </p:cNvPicPr>
+          <p:nvPr/>
+        </p:nvPicPr>
+        <p:blipFill>
+          <a:blip r:embed="rId2"/>
+          <a:stretch>
+            <a:fillRect/>
+          </a:stretch>
+        </p:blipFill>
+        <p:spPr>
+          <a:xfrm>
+            <a:off x="3609137" y="1499616"/>
+            <a:ext cx="237744" cy="237744"/>
+          </a:xfrm>
+          <a:prstGeom prst="rect">
+            <a:avLst/>
+          </a:prstGeom>
+        </p:spPr>
+      </p:pic>
+      <p:sp>
+        <p:nvSpPr>
+          <p:cNvPr id="12" name="Text 8"/>
+          <p:cNvSpPr txBox="1"/>
+          <p:nvPr/>
+        </p:nvSpPr>
+        <p:spPr>
+          <a:xfrm>
+            <a:off x="4048049" y="1371600"/>
+            <a:ext cx="1874520" cy="548640"/>
+          </a:xfrm>
+          <a:prstGeom prst="rect">
+            <a:avLst/>
+          </a:prstGeom>
+          <a:noFill/>
+          <a:ln/>
+        </p:spPr>
+        <p:txBody>
+          <a:bodyPr wrap="square" lIns="0" tIns="0" rIns="0" bIns="0" rtlCol="0" anchor="ctr"/>
+          <a:lstStyle/>
+          <a:p>
+            <a:pPr indent="0" marL="0">
+              <a:buNone/>
+            </a:pPr>
+            <a:r>
+              <a:rPr lang="en-US" sz="1500" b="1" dirty="0">
+                <a:solidFill>
+                  <a:srgbClr val="16261F"/>
+                </a:solidFill>
+                <a:latin typeface="Calibri" pitchFamily="34" charset="0"/>
+                <a:ea typeface="Calibri" pitchFamily="34" charset="-122"/>
+                <a:cs typeface="Calibri" pitchFamily="34" charset="-120"/>
+              </a:rPr>
+              <a:t>Adithyaa J</a:t>
+            </a:r>
+            <a:endParaRPr lang="en-US" sz="1500" dirty="0"/>
+          </a:p>
+          <a:p>
+            <a:pPr indent="0" marL="0">
+              <a:buNone/>
+            </a:pPr>
+            <a:r>
+              <a:rPr lang="en-US" sz="1100" b="1" dirty="0">
+                <a:solidFill>
+                  <a:srgbClr val="0E5A32"/>
+                </a:solidFill>
+                <a:latin typeface="Calibri" pitchFamily="34" charset="0"/>
+                <a:ea typeface="Calibri" pitchFamily="34" charset="-122"/>
+                <a:cs typeface="Calibri" pitchFamily="34" charset="-120"/>
+              </a:rPr>
+              <a:t>Embedded Hardware</a:t>
+            </a:r>
+            <a:endParaRPr lang="en-US" sz="1500" dirty="0"/>
+          </a:p>
+        </p:txBody>
+      </p:sp>
+      <p:sp>
+        <p:nvSpPr>
+          <p:cNvPr id="13" name="Text 9"/>
+          <p:cNvSpPr txBox="1"/>
+          <p:nvPr/>
+        </p:nvSpPr>
+        <p:spPr>
+          <a:xfrm>
+            <a:off x="3499409" y="2011680"/>
+            <a:ext cx="2377440" cy="1005840"/>
+          </a:xfrm>
+          <a:prstGeom prst="rect">
+            <a:avLst/>
+          </a:prstGeom>
+          <a:noFill/>
+          <a:ln/>
+        </p:spPr>
+        <p:txBody>
+          <a:bodyPr wrap="square" lIns="0" tIns="0" rIns="0" bIns="0" rtlCol="0" anchor="t"/>
+          <a:lstStyle/>
+          <a:p>
+            <a:pPr indent="0" marL="0">
+              <a:buNone/>
+            </a:pPr>
+            <a:r>
+              <a:rPr lang="en-US" sz="1150" dirty="0">
+                <a:solidFill>
+                  <a:srgbClr val="55655D"/>
+                </a:solidFill>
+                <a:latin typeface="Calibri" pitchFamily="34" charset="0"/>
+                <a:ea typeface="Calibri" pitchFamily="34" charset="-122"/>
+                <a:cs typeface="Calibri" pitchFamily="34" charset="-120"/>
+              </a:rPr>
+              <a:t>ESP32 logger, power clamp and pressure-sensor integration</a:t>
+            </a:r>
+            <a:endParaRPr lang="en-US" sz="1150" dirty="0"/>
+          </a:p>
+        </p:txBody>
+      </p:sp>
+      <p:sp>
+        <p:nvSpPr>
+          <p:cNvPr id="14" name="Shape 10"/>
+          <p:cNvSpPr/>
+          <p:nvPr/>
+        </p:nvSpPr>
+        <p:spPr>
+          <a:xfrm>
+            <a:off x="6175858" y="1280160"/>
+            <a:ext cx="2651760" cy="1783080"/>
+          </a:xfrm>
+          <a:prstGeom prst="roundRect">
+            <a:avLst>
+              <a:gd name="adj" fmla="val 4103"/>
+            </a:avLst>
+          </a:prstGeom>
+          <a:solidFill>
+            <a:srgbClr val="FFFFFF"/>
+          </a:solidFill>
+          <a:ln w="12700">
+            <a:solidFill>
+              <a:srgbClr val="D3DFD7"/>
+            </a:solidFill>
+            <a:prstDash val="solid"/>
+          </a:ln>
+        </p:spPr>
+      </p:sp>
+      <p:sp>
+        <p:nvSpPr>
+          <p:cNvPr id="15" name="Shape 11"/>
+          <p:cNvSpPr/>
+          <p:nvPr/>
+        </p:nvSpPr>
+        <p:spPr>
+          <a:xfrm>
+            <a:off x="6313018" y="1389888"/>
+            <a:ext cx="457200" cy="457200"/>
+          </a:xfrm>
+          <a:prstGeom prst="ellipse">
+            <a:avLst/>
+          </a:prstGeom>
+          <a:solidFill>
+            <a:srgbClr val="0E5A32"/>
+          </a:solidFill>
+          <a:ln w="12700">
+            <a:solidFill>
+              <a:srgbClr val="0E5A32"/>
+            </a:solidFill>
+            <a:prstDash val="solid"/>
+          </a:ln>
+        </p:spPr>
+      </p:sp>
+      <p:pic>
+        <p:nvPicPr>
+          <p:cNvPr id="16" name="Image 2" descr="preencoded.png">    </p:cNvPr>
+          <p:cNvPicPr>
+            <a:picLocks noChangeAspect="1"/>
+          </p:cNvPicPr>
+          <p:nvPr/>
+        </p:nvPicPr>
+        <p:blipFill>
+          <a:blip r:embed="rId3"/>
+          <a:stretch>
+            <a:fillRect/>
+          </a:stretch>
+        </p:blipFill>
+        <p:spPr>
+          <a:xfrm>
+            <a:off x="6422746" y="1499616"/>
+            <a:ext cx="237744" cy="237744"/>
+          </a:xfrm>
+          <a:prstGeom prst="rect">
+            <a:avLst/>
+          </a:prstGeom>
+        </p:spPr>
+      </p:pic>
+      <p:sp>
+        <p:nvSpPr>
+          <p:cNvPr id="17" name="Text 12"/>
+          <p:cNvSpPr txBox="1"/>
+          <p:nvPr/>
+        </p:nvSpPr>
+        <p:spPr>
+          <a:xfrm>
+            <a:off x="6861658" y="1371600"/>
+            <a:ext cx="1874520" cy="548640"/>
+          </a:xfrm>
+          <a:prstGeom prst="rect">
+            <a:avLst/>
+          </a:prstGeom>
+          <a:noFill/>
+          <a:ln/>
+        </p:spPr>
+        <p:txBody>
+          <a:bodyPr wrap="square" lIns="0" tIns="0" rIns="0" bIns="0" rtlCol="0" anchor="ctr"/>
+          <a:lstStyle/>
+          <a:p>
+            <a:pPr indent="0" marL="0">
+              <a:buNone/>
+            </a:pPr>
+            <a:r>
+              <a:rPr lang="en-US" sz="1500" b="1" dirty="0">
+                <a:solidFill>
+                  <a:srgbClr val="16261F"/>
+                </a:solidFill>
+                <a:latin typeface="Calibri" pitchFamily="34" charset="0"/>
+                <a:ea typeface="Calibri" pitchFamily="34" charset="-122"/>
+                <a:cs typeface="Calibri" pitchFamily="34" charset="-120"/>
+              </a:rPr>
+              <a:t>Nikilaesh B</a:t>
+            </a:r>
+            <a:endParaRPr lang="en-US" sz="1500" dirty="0"/>
+          </a:p>
+          <a:p>
+            <a:pPr indent="0" marL="0">
+              <a:buNone/>
+            </a:pPr>
+            <a:r>
+              <a:rPr lang="en-US" sz="1100" b="1" dirty="0">
+                <a:solidFill>
+                  <a:srgbClr val="0E5A32"/>
+                </a:solidFill>
+                <a:latin typeface="Calibri" pitchFamily="34" charset="0"/>
+                <a:ea typeface="Calibri" pitchFamily="34" charset="-122"/>
+                <a:cs typeface="Calibri" pitchFamily="34" charset="-120"/>
+              </a:rPr>
+              <a:t>Energy Analytics</a:t>
+            </a:r>
+            <a:endParaRPr lang="en-US" sz="1500" dirty="0"/>
+          </a:p>
+        </p:txBody>
+      </p:sp>
+      <p:sp>
+        <p:nvSpPr>
+          <p:cNvPr id="18" name="Text 13"/>
+          <p:cNvSpPr txBox="1"/>
+          <p:nvPr/>
+        </p:nvSpPr>
+        <p:spPr>
+          <a:xfrm>
+            <a:off x="6313018" y="2011680"/>
+            <a:ext cx="2377440" cy="1005840"/>
+          </a:xfrm>
+          <a:prstGeom prst="rect">
+            <a:avLst/>
+          </a:prstGeom>
+          <a:noFill/>
+          <a:ln/>
+        </p:spPr>
+        <p:txBody>
+          <a:bodyPr wrap="square" lIns="0" tIns="0" rIns="0" bIns="0" rtlCol="0" anchor="t"/>
+          <a:lstStyle/>
+          <a:p>
+            <a:pPr indent="0" marL="0">
+              <a:buNone/>
+            </a:pPr>
+            <a:r>
+              <a:rPr lang="en-US" sz="1150" dirty="0">
+                <a:solidFill>
+                  <a:srgbClr val="55655D"/>
+                </a:solidFill>
+                <a:latin typeface="Calibri" pitchFamily="34" charset="0"/>
+                <a:ea typeface="Calibri" pitchFamily="34" charset="-122"/>
+                <a:cs typeface="Calibri" pitchFamily="34" charset="-120"/>
+              </a:rPr>
+              <a:t>Pump hydraulics model, Shapley waste split and VFD payback logic</a:t>
+            </a:r>
+            <a:endParaRPr lang="en-US" sz="1150" dirty="0"/>
+          </a:p>
+        </p:txBody>
+      </p:sp>
+      <p:sp>
+        <p:nvSpPr>
+          <p:cNvPr id="19" name="Shape 14"/>
+          <p:cNvSpPr/>
+          <p:nvPr/>
+        </p:nvSpPr>
+        <p:spPr>
+          <a:xfrm>
+            <a:off x="8989466" y="1280160"/>
+            <a:ext cx="2651760" cy="1783080"/>
+          </a:xfrm>
+          <a:prstGeom prst="roundRect">
+            <a:avLst>
+              <a:gd name="adj" fmla="val 4103"/>
+            </a:avLst>
+          </a:prstGeom>
+          <a:solidFill>
+            <a:srgbClr val="FFFFFF"/>
+          </a:solidFill>
+          <a:ln w="12700">
+            <a:solidFill>
+              <a:srgbClr val="D3DFD7"/>
+            </a:solidFill>
+            <a:prstDash val="solid"/>
+          </a:ln>
+        </p:spPr>
+      </p:sp>
+      <p:sp>
+        <p:nvSpPr>
+          <p:cNvPr id="20" name="Shape 15"/>
+          <p:cNvSpPr/>
+          <p:nvPr/>
+        </p:nvSpPr>
+        <p:spPr>
+          <a:xfrm>
+            <a:off x="9126626" y="1389888"/>
+            <a:ext cx="457200" cy="457200"/>
+          </a:xfrm>
+          <a:prstGeom prst="ellipse">
+            <a:avLst/>
+          </a:prstGeom>
+          <a:solidFill>
+            <a:srgbClr val="0E5A32"/>
+          </a:solidFill>
+          <a:ln w="12700">
+            <a:solidFill>
+              <a:srgbClr val="0E5A32"/>
+            </a:solidFill>
+            <a:prstDash val="solid"/>
+          </a:ln>
+        </p:spPr>
+      </p:sp>
+      <p:pic>
+        <p:nvPicPr>
+          <p:cNvPr id="21" name="Image 3" descr="preencoded.png">    </p:cNvPr>
+          <p:cNvPicPr>
+            <a:picLocks noChangeAspect="1"/>
+          </p:cNvPicPr>
+          <p:nvPr/>
+        </p:nvPicPr>
+        <p:blipFill>
+          <a:blip r:embed="rId4"/>
+          <a:stretch>
+            <a:fillRect/>
+          </a:stretch>
+        </p:blipFill>
+        <p:spPr>
+          <a:xfrm>
+            <a:off x="9236354" y="1499616"/>
+            <a:ext cx="237744" cy="237744"/>
+          </a:xfrm>
+          <a:prstGeom prst="rect">
+            <a:avLst/>
+          </a:prstGeom>
+        </p:spPr>
+      </p:pic>
+      <p:sp>
+        <p:nvSpPr>
+          <p:cNvPr id="22" name="Text 16"/>
+          <p:cNvSpPr txBox="1"/>
+          <p:nvPr/>
+        </p:nvSpPr>
+        <p:spPr>
+          <a:xfrm>
+            <a:off x="9675266" y="1371600"/>
+            <a:ext cx="1874520" cy="548640"/>
+          </a:xfrm>
+          <a:prstGeom prst="rect">
+            <a:avLst/>
+          </a:prstGeom>
+          <a:noFill/>
+          <a:ln/>
+        </p:spPr>
+        <p:txBody>
+          <a:bodyPr wrap="square" lIns="0" tIns="0" rIns="0" bIns="0" rtlCol="0" anchor="ctr"/>
+          <a:lstStyle/>
+          <a:p>
+            <a:pPr indent="0" marL="0">
+              <a:buNone/>
+            </a:pPr>
+            <a:r>
+              <a:rPr lang="en-US" sz="1500" b="1" dirty="0">
+                <a:solidFill>
+                  <a:srgbClr val="16261F"/>
+                </a:solidFill>
+                <a:latin typeface="Calibri" pitchFamily="34" charset="0"/>
+                <a:ea typeface="Calibri" pitchFamily="34" charset="-122"/>
+                <a:cs typeface="Calibri" pitchFamily="34" charset="-120"/>
+              </a:rPr>
+              <a:t>Siva Subramaniam S</a:t>
+            </a:r>
+            <a:endParaRPr lang="en-US" sz="1500" dirty="0"/>
+          </a:p>
+          <a:p>
+            <a:pPr indent="0" marL="0">
+              <a:buNone/>
+            </a:pPr>
+            <a:r>
+              <a:rPr lang="en-US" sz="1100" b="1" dirty="0">
+                <a:solidFill>
+                  <a:srgbClr val="0E5A32"/>
+                </a:solidFill>
+                <a:latin typeface="Calibri" pitchFamily="34" charset="0"/>
+                <a:ea typeface="Calibri" pitchFamily="34" charset="-122"/>
+                <a:cs typeface="Calibri" pitchFamily="34" charset="-120"/>
+              </a:rPr>
+              <a:t>Simulation &amp; Validation</a:t>
+            </a:r>
+            <a:endParaRPr lang="en-US" sz="1500" dirty="0"/>
+          </a:p>
+        </p:txBody>
+      </p:sp>
+      <p:sp>
+        <p:nvSpPr>
+          <p:cNvPr id="23" name="Text 17"/>
+          <p:cNvSpPr txBox="1"/>
+          <p:nvPr/>
+        </p:nvSpPr>
+        <p:spPr>
+          <a:xfrm>
+            <a:off x="9126626" y="2011680"/>
+            <a:ext cx="2377440" cy="1005840"/>
+          </a:xfrm>
+          <a:prstGeom prst="rect">
+            <a:avLst/>
+          </a:prstGeom>
+          <a:noFill/>
+          <a:ln/>
+        </p:spPr>
+        <p:txBody>
+          <a:bodyPr wrap="square" lIns="0" tIns="0" rIns="0" bIns="0" rtlCol="0" anchor="t"/>
+          <a:lstStyle/>
+          <a:p>
+            <a:pPr indent="0" marL="0">
+              <a:buNone/>
+            </a:pPr>
+            <a:r>
+              <a:rPr lang="en-US" sz="1150" dirty="0">
+                <a:solidFill>
+                  <a:srgbClr val="55655D"/>
+                </a:solidFill>
+                <a:latin typeface="Calibri" pitchFamily="34" charset="0"/>
+                <a:ea typeface="Calibri" pitchFamily="34" charset="-122"/>
+                <a:cs typeface="Calibri" pitchFamily="34" charset="-120"/>
+              </a:rPr>
+              <a:t>Pump-curve simulation, CUSUM wear-drift testing, pilot and roadmap planning</a:t>
+            </a:r>
+            <a:endParaRPr lang="en-US" sz="1150" dirty="0"/>
+          </a:p>
+        </p:txBody>
+      </p:sp>
+      <p:sp>
+        <p:nvSpPr>
+          <p:cNvPr id="24" name="Shape 18"/>
+          <p:cNvSpPr/>
+          <p:nvPr/>
+        </p:nvSpPr>
+        <p:spPr>
+          <a:xfrm>
+            <a:off x="548640" y="3200400"/>
+            <a:ext cx="11109960" cy="2331720"/>
+          </a:xfrm>
+          <a:prstGeom prst="roundRect">
+            <a:avLst>
+              <a:gd name="adj" fmla="val 3137"/>
+            </a:avLst>
+          </a:prstGeom>
+          <a:solidFill>
+            <a:srgbClr val="FFFFFF"/>
+          </a:solidFill>
+          <a:ln w="12700">
+            <a:solidFill>
+              <a:srgbClr val="D3DFD7"/>
+            </a:solidFill>
+            <a:prstDash val="solid"/>
+          </a:ln>
+        </p:spPr>
+      </p:sp>
+      <p:sp>
+        <p:nvSpPr>
+          <p:cNvPr id="25" name="Text 19"/>
+          <p:cNvSpPr txBox="1"/>
+          <p:nvPr/>
+        </p:nvSpPr>
+        <p:spPr>
+          <a:xfrm>
+            <a:off x="685800" y="3246120"/>
+            <a:ext cx="5486400" cy="292608"/>
+          </a:xfrm>
+          <a:prstGeom prst="rect">
+            <a:avLst/>
+          </a:prstGeom>
+          <a:noFill/>
+          <a:ln/>
+        </p:spPr>
+        <p:txBody>
+          <a:bodyPr wrap="square" lIns="0" tIns="0" rIns="0" bIns="0" rtlCol="0" anchor="t"/>
+          <a:lstStyle/>
+          <a:p>
+            <a:pPr indent="0" marL="0">
+              <a:buNone/>
+            </a:pPr>
+            <a:r>
+              <a:rPr lang="en-US" sz="1400" b="1" dirty="0">
+                <a:solidFill>
+                  <a:srgbClr val="0E5A32"/>
+                </a:solidFill>
+                <a:latin typeface="Calibri" pitchFamily="34" charset="0"/>
+                <a:ea typeface="Calibri" pitchFamily="34" charset="-122"/>
+                <a:cs typeface="Calibri" pitchFamily="34" charset="-120"/>
+              </a:rPr>
+              <a:t>References &amp; data sources</a:t>
+            </a:r>
+            <a:endParaRPr lang="en-US" sz="1400" dirty="0"/>
+          </a:p>
+        </p:txBody>
+      </p:sp>
+      <p:sp>
+        <p:nvSpPr>
+          <p:cNvPr id="26" name="Text 20"/>
+          <p:cNvSpPr txBox="1"/>
+          <p:nvPr/>
+        </p:nvSpPr>
+        <p:spPr>
+          <a:xfrm>
+            <a:off x="685800" y="3566160"/>
+            <a:ext cx="5349240" cy="1920240"/>
+          </a:xfrm>
+          <a:prstGeom prst="rect">
+            <a:avLst/>
+          </a:prstGeom>
+          <a:noFill/>
+          <a:ln/>
+        </p:spPr>
+        <p:txBody>
+          <a:bodyPr wrap="square" lIns="0" tIns="0" rIns="0" bIns="0" rtlCol="0" anchor="t"/>
+          <a:lstStyle/>
+          <a:p>
+            <a:pPr marL="342900" indent="-342900">
+              <a:spcAft>
+                <a:spcPts val="300"/>
+              </a:spcAft>
+              <a:buSzPct val="100000"/>
+              <a:buChar char="•"/>
+            </a:pPr>
+            <a:r>
+              <a:rPr lang="en-US" sz="950" dirty="0">
+                <a:solidFill>
+                  <a:srgbClr val="16261F"/>
+                </a:solidFill>
+                <a:latin typeface="Calibri" pitchFamily="34" charset="0"/>
+                <a:ea typeface="Calibri" pitchFamily="34" charset="-122"/>
+                <a:cs typeface="Calibri" pitchFamily="34" charset="-120"/>
+              </a:rPr>
+              <a:t>Pump data: Grundfos Product Center duty-point readouts for NB 65-160/157 (product no. 97839240), retrieved 2026-10-02. Curve tolerance ISO 9906:2012 Grade 3B. Curves in this deck are cubic fits to those 14 points.</a:t>
+            </a:r>
+            <a:endParaRPr lang="en-US" sz="950" dirty="0"/>
+          </a:p>
+          <a:p>
+            <a:pPr marL="342900" indent="-342900">
+              <a:spcAft>
+                <a:spcPts val="300"/>
+              </a:spcAft>
+              <a:buSzPct val="100000"/>
+              <a:buChar char="•"/>
+            </a:pPr>
+            <a:r>
+              <a:rPr lang="en-US" sz="950" dirty="0">
+                <a:solidFill>
+                  <a:srgbClr val="16261F"/>
+                </a:solidFill>
+                <a:latin typeface="Calibri" pitchFamily="34" charset="0"/>
+                <a:ea typeface="Calibri" pitchFamily="34" charset="-122"/>
+                <a:cs typeface="Calibri" pitchFamily="34" charset="-120"/>
+              </a:rPr>
+              <a:t>Emission factor: CEA CO₂ Baseline Database for the Indian Power Sector, v21.0 (FY2024-25): 0.710 kg CO₂/kWh.</a:t>
+            </a:r>
+            <a:endParaRPr lang="en-US" sz="950" dirty="0"/>
+          </a:p>
+          <a:p>
+            <a:pPr marL="342900" indent="-342900">
+              <a:spcAft>
+                <a:spcPts val="300"/>
+              </a:spcAft>
+              <a:buSzPct val="100000"/>
+              <a:buChar char="•"/>
+            </a:pPr>
+            <a:r>
+              <a:rPr lang="en-US" sz="950" dirty="0">
+                <a:solidFill>
+                  <a:srgbClr val="16261F"/>
+                </a:solidFill>
+                <a:latin typeface="Calibri" pitchFamily="34" charset="0"/>
+                <a:ea typeface="Calibri" pitchFamily="34" charset="-122"/>
+                <a:cs typeface="Calibri" pitchFamily="34" charset="-120"/>
+              </a:rPr>
+              <a:t>Energy-audit practitioner input (paraphrased, not named): wrong sizing is the most common cause of throttling; 30–40% of ultrasonic flow readings go wrong.</a:t>
+            </a:r>
+            <a:endParaRPr lang="en-US" sz="950" dirty="0"/>
+          </a:p>
+          <a:p>
+            <a:pPr marL="342900" indent="-342900">
+              <a:spcAft>
+                <a:spcPts val="300"/>
+              </a:spcAft>
+              <a:buSzPct val="100000"/>
+              <a:buChar char="•"/>
+            </a:pPr>
+            <a:r>
+              <a:rPr lang="en-US" sz="950" dirty="0">
+                <a:solidFill>
+                  <a:srgbClr val="16261F"/>
+                </a:solidFill>
+                <a:latin typeface="Calibri" pitchFamily="34" charset="0"/>
+                <a:ea typeface="Calibri" pitchFamily="34" charset="-122"/>
+                <a:cs typeface="Calibri" pitchFamily="34" charset="-120"/>
+              </a:rPr>
+              <a:t>Method: affinity laws; Shapley value attribution; CUSUM change detection; IPMVP-style measurement and verification.</a:t>
+            </a:r>
+            <a:endParaRPr lang="en-US" sz="950" dirty="0"/>
+          </a:p>
+        </p:txBody>
+      </p:sp>
+      <p:sp>
+        <p:nvSpPr>
+          <p:cNvPr id="27" name="Text 21"/>
+          <p:cNvSpPr txBox="1"/>
+          <p:nvPr/>
+        </p:nvSpPr>
+        <p:spPr>
+          <a:xfrm>
+            <a:off x="6217920" y="3566160"/>
+            <a:ext cx="5349240" cy="1920240"/>
+          </a:xfrm>
+          <a:prstGeom prst="rect">
+            <a:avLst/>
+          </a:prstGeom>
+          <a:noFill/>
+          <a:ln/>
+        </p:spPr>
+        <p:txBody>
+          <a:bodyPr wrap="square" lIns="0" tIns="0" rIns="0" bIns="0" rtlCol="0" anchor="t"/>
+          <a:lstStyle/>
+          <a:p>
+            <a:pPr marL="342900" indent="-342900">
+              <a:spcAft>
+                <a:spcPts val="300"/>
+              </a:spcAft>
+              <a:buSzPct val="100000"/>
+              <a:buChar char="•"/>
+            </a:pPr>
+            <a:r>
+              <a:rPr lang="en-US" sz="950" dirty="0">
+                <a:solidFill>
+                  <a:srgbClr val="16261F"/>
+                </a:solidFill>
+                <a:latin typeface="Calibri" pitchFamily="34" charset="0"/>
+                <a:ea typeface="Calibri" pitchFamily="34" charset="-122"/>
+                <a:cs typeface="Calibri" pitchFamily="34" charset="-120"/>
+              </a:rPr>
+              <a:t>Component prices (indicative online listings, 2026-10-02, not quotes): ESP32 (Robu); SCT-013 clamp (ElectronicsComp, Robodo, Robocraze); ZMPT101B voltage sensor; 4–20 mA pressure transmitters (Nishka, Utopia, Shri Instruments); VFDs (Delta MS300 listing, Industrybuying). Install cost ₹15,000 is an assumption.</a:t>
+            </a:r>
+            <a:endParaRPr lang="en-US" sz="950" dirty="0"/>
+          </a:p>
+          <a:p>
+            <a:pPr marL="342900" indent="-342900">
+              <a:spcAft>
+                <a:spcPts val="300"/>
+              </a:spcAft>
+              <a:buSzPct val="100000"/>
+              <a:buChar char="•"/>
+            </a:pPr>
+            <a:r>
+              <a:rPr lang="en-US" sz="950" dirty="0">
+                <a:solidFill>
+                  <a:srgbClr val="16261F"/>
+                </a:solidFill>
+                <a:latin typeface="Calibri" pitchFamily="34" charset="0"/>
+                <a:ea typeface="Calibri" pitchFamily="34" charset="-122"/>
+                <a:cs typeface="Calibri" pitchFamily="34" charset="-120"/>
+              </a:rPr>
+              <a:t>Prior art: KSB PumpMeter, US DOE PSAT, Samotics, Schneider Altivar Process and EcoStruxure, Indian IoT vendors and ESCOs.</a:t>
+            </a:r>
+            <a:endParaRPr lang="en-US" sz="950" dirty="0"/>
+          </a:p>
+          <a:p>
+            <a:pPr marL="342900" indent="-342900">
+              <a:spcAft>
+                <a:spcPts val="300"/>
+              </a:spcAft>
+              <a:buSzPct val="100000"/>
+              <a:buChar char="•"/>
+            </a:pPr>
+            <a:r>
+              <a:rPr lang="en-US" sz="950" dirty="0">
+                <a:solidFill>
+                  <a:srgbClr val="16261F"/>
+                </a:solidFill>
+                <a:latin typeface="Calibri" pitchFamily="34" charset="0"/>
+                <a:ea typeface="Calibri" pitchFamily="34" charset="-122"/>
+                <a:cs typeface="Calibri" pitchFamily="34" charset="-120"/>
+              </a:rPr>
+              <a:t>Simulation: our open Python scripts (fixed seeds) in the project repository, folder yuva_yodha/; dashboard source in yuva_yodha/dashboard/.</a:t>
+            </a:r>
+            <a:endParaRPr lang="en-US" sz="950" dirty="0"/>
+          </a:p>
+          <a:p>
+            <a:pPr marL="342900" indent="-342900">
+              <a:spcAft>
+                <a:spcPts val="300"/>
+              </a:spcAft>
+              <a:buSzPct val="100000"/>
+              <a:buChar char="•"/>
+            </a:pPr>
+            <a:r>
+              <a:rPr lang="en-US" sz="950" dirty="0">
+                <a:solidFill>
+                  <a:srgbClr val="16261F"/>
+                </a:solidFill>
+                <a:latin typeface="Calibri" pitchFamily="34" charset="0"/>
+                <a:ea typeface="Calibri" pitchFamily="34" charset="-122"/>
+                <a:cs typeface="Calibri" pitchFamily="34" charset="-120"/>
+              </a:rPr>
+              <a:t>All results are simulated. No lab or field data.</a:t>
+            </a:r>
+            <a:endParaRPr lang="en-US" sz="950" dirty="0"/>
+          </a:p>
+        </p:txBody>
+      </p:sp>
+      <p:pic>
+        <p:nvPicPr>
+          <p:cNvPr id="28" name="Image 4" descr="preencoded.png">    </p:cNvPr>
+          <p:cNvPicPr>
+            <a:picLocks noChangeAspect="1"/>
+          </p:cNvPicPr>
+          <p:nvPr/>
+        </p:nvPicPr>
+        <p:blipFill>
+          <a:blip r:embed="rId5"/>
+          <a:stretch>
+            <a:fillRect/>
+          </a:stretch>
+        </p:blipFill>
+        <p:spPr>
+          <a:xfrm>
+            <a:off x="548640" y="5623560"/>
+            <a:ext cx="777240" cy="777240"/>
+          </a:xfrm>
+          <a:prstGeom prst="rect">
+            <a:avLst/>
+          </a:prstGeom>
+        </p:spPr>
+      </p:pic>
+      <p:sp>
+        <p:nvSpPr>
+          <p:cNvPr id="29" name="Text 22"/>
+          <p:cNvSpPr txBox="1"/>
+          <p:nvPr/>
+        </p:nvSpPr>
+        <p:spPr>
+          <a:xfrm>
+            <a:off x="1463040" y="5696712"/>
+            <a:ext cx="3840480" cy="777240"/>
+          </a:xfrm>
+          <a:prstGeom prst="rect">
+            <a:avLst/>
+          </a:prstGeom>
+          <a:noFill/>
+          <a:ln/>
+        </p:spPr>
+        <p:txBody>
+          <a:bodyPr wrap="square" lIns="0" tIns="0" rIns="0" bIns="0" rtlCol="0" anchor="t"/>
+          <a:lstStyle/>
+          <a:p>
+            <a:pPr indent="0" marL="0">
+              <a:buNone/>
+            </a:pPr>
+            <a:r>
               <a:rPr lang="en-US" sz="1300" b="1" dirty="0">
                 <a:solidFill>
                   <a:srgbClr val="0E5A32"/>
@@ -5966,7 +5421,7 @@
                 <a:latin typeface="Calibri" pitchFamily="34" charset="0"/>
                 <a:ea typeface="Calibri" pitchFamily="34" charset="-122"/>
                 <a:cs typeface="Calibri" pitchFamily="34" charset="-120"/>
-                <a:hlinkClick r:id="rId2" invalidUrl="" action="" tgtFrame="" tooltip="" history="1" highlightClick="0" endSnd="0">
+                <a:hlinkClick r:id="rId6" invalidUrl="" action="" tgtFrame="" tooltip="" history="1" highlightClick="0" endSnd="0">
                   <a:extLst>
                     <a:ext uri="{A12FA001-AC4F-418D-AE19-62706E023703}">
                       <ahyp:hlinkClr xmlns:ahyp="http://schemas.microsoft.com/office/drawing/2018/hyperlinkcolor" val="tx"/>
@@ -5999,14 +5454,14 @@
       </p:sp>
       <p:sp>
         <p:nvSpPr>
-          <p:cNvPr id="22" name="Text 19"/>
-          <p:cNvSpPr txBox="1"/>
-          <p:nvPr/>
-        </p:nvSpPr>
-        <p:spPr>
-          <a:xfrm>
-            <a:off x="5852160" y="5257800"/>
-            <a:ext cx="5806440" cy="731520"/>
+          <p:cNvPr id="30" name="Text 23"/>
+          <p:cNvSpPr txBox="1"/>
+          <p:nvPr/>
+        </p:nvSpPr>
+        <p:spPr>
+          <a:xfrm>
+            <a:off x="5852160" y="5669280"/>
+            <a:ext cx="5806440" cy="685800"/>
           </a:xfrm>
           <a:prstGeom prst="rect">
             <a:avLst/>
@@ -6022,7 +5477,7 @@
               <a:buNone/>
             </a:pPr>
             <a:r>
-              <a:rPr lang="en-US" sz="2400" b="1" dirty="0">
+              <a:rPr lang="en-US" sz="2200" b="1" dirty="0">
                 <a:solidFill>
                   <a:srgbClr val="0E5A32"/>
                 </a:solidFill>
@@ -6032,7 +5487,7 @@
               </a:rPr>
               <a:t>Cheap kit. Clever inference. Answers in rupees.</a:t>
             </a:r>
-            <a:endParaRPr lang="en-US" sz="2400" dirty="0"/>
+            <a:endParaRPr lang="en-US" sz="2200" dirty="0"/>
           </a:p>
         </p:txBody>
       </p:sp>
@@ -14148,7 +13603,7 @@
         <p:spPr>
           <a:xfrm>
             <a:off x="548640" y="3611880"/>
-            <a:ext cx="5989320" cy="2697480"/>
+            <a:ext cx="3611880" cy="2697480"/>
           </a:xfrm>
           <a:prstGeom prst="roundRect">
             <a:avLst>
@@ -14175,7 +13630,7 @@
         <p:spPr>
           <a:xfrm>
             <a:off x="658368" y="3657600"/>
-            <a:ext cx="5760720" cy="256032"/>
+            <a:ext cx="3429000" cy="256032"/>
           </a:xfrm>
           <a:prstGeom prst="rect">
             <a:avLst/>
@@ -14191,6 +13646,135 @@
               <a:buNone/>
             </a:pPr>
             <a:r>
+              <a:rPr lang="en-US" sz="1100" b="1" dirty="0">
+                <a:solidFill>
+                  <a:srgbClr val="0E5A32"/>
+                </a:solidFill>
+                <a:latin typeface="Calibri" pitchFamily="34" charset="0"/>
+                <a:ea typeface="Calibri" pitchFamily="34" charset="-122"/>
+                <a:cs typeface="Calibri" pitchFamily="34" charset="-120"/>
+              </a:rPr>
+              <a:t>Grundfos NB 65-160/157 curves</a:t>
+            </a:r>
+            <a:endParaRPr lang="en-US" sz="1100" dirty="0"/>
+          </a:p>
+        </p:txBody>
+      </p:sp>
+      <p:pic>
+        <p:nvPicPr>
+          <p:cNvPr id="33" name="Image 0" descr="preencoded.png">    </p:cNvPr>
+          <p:cNvPicPr>
+            <a:picLocks noChangeAspect="1"/>
+          </p:cNvPicPr>
+          <p:nvPr/>
+        </p:nvPicPr>
+        <p:blipFill>
+          <a:blip r:embed="rId1"/>
+          <a:stretch>
+            <a:fillRect/>
+          </a:stretch>
+        </p:blipFill>
+        <p:spPr>
+          <a:xfrm>
+            <a:off x="621792" y="3931920"/>
+            <a:ext cx="3474720" cy="2057400"/>
+          </a:xfrm>
+          <a:prstGeom prst="rect">
+            <a:avLst/>
+          </a:prstGeom>
+        </p:spPr>
+      </p:pic>
+      <p:sp>
+        <p:nvSpPr>
+          <p:cNvPr id="34" name="Text 31"/>
+          <p:cNvSpPr txBox="1"/>
+          <p:nvPr/>
+        </p:nvSpPr>
+        <p:spPr>
+          <a:xfrm>
+            <a:off x="658368" y="6053328"/>
+            <a:ext cx="3429000" cy="228600"/>
+          </a:xfrm>
+          <a:prstGeom prst="rect">
+            <a:avLst/>
+          </a:prstGeom>
+          <a:noFill/>
+          <a:ln/>
+        </p:spPr>
+        <p:txBody>
+          <a:bodyPr wrap="square" lIns="0" tIns="0" rIns="0" bIns="0" rtlCol="0" anchor="t"/>
+          <a:lstStyle/>
+          <a:p>
+            <a:pPr indent="0" marL="0">
+              <a:buNone/>
+            </a:pPr>
+            <a:r>
+              <a:rPr lang="en-US" sz="900" i="1" dirty="0">
+                <a:solidFill>
+                  <a:srgbClr val="55655D"/>
+                </a:solidFill>
+                <a:latin typeface="Calibri" pitchFamily="34" charset="0"/>
+                <a:ea typeface="Calibri" pitchFamily="34" charset="-122"/>
+                <a:cs typeface="Calibri" pitchFamily="34" charset="-120"/>
+              </a:rPr>
+              <a:t>Off-peak 61.6 m³/h. Simulated; the system curve is assumed.</a:t>
+            </a:r>
+            <a:endParaRPr lang="en-US" sz="900" dirty="0"/>
+          </a:p>
+        </p:txBody>
+      </p:sp>
+      <p:sp>
+        <p:nvSpPr>
+          <p:cNvPr id="35" name="Shape 32"/>
+          <p:cNvSpPr/>
+          <p:nvPr/>
+        </p:nvSpPr>
+        <p:spPr>
+          <a:xfrm>
+            <a:off x="4297680" y="3611880"/>
+            <a:ext cx="2240280" cy="2697480"/>
+          </a:xfrm>
+          <a:prstGeom prst="roundRect">
+            <a:avLst>
+              <a:gd name="adj" fmla="val 3265"/>
+            </a:avLst>
+          </a:prstGeom>
+          <a:solidFill>
+            <a:srgbClr val="E3F6E8"/>
+          </a:solidFill>
+          <a:ln w="19050">
+            <a:solidFill>
+              <a:srgbClr val="3DCD58"/>
+            </a:solidFill>
+            <a:prstDash val="solid"/>
+          </a:ln>
+        </p:spPr>
+      </p:sp>
+      <p:sp>
+        <p:nvSpPr>
+          <p:cNvPr id="36" name="Text 33"/>
+          <p:cNvSpPr txBox="1"/>
+          <p:nvPr/>
+        </p:nvSpPr>
+        <p:spPr>
+          <a:xfrm>
+            <a:off x="4389120" y="3657600"/>
+            <a:ext cx="2103120" cy="274320"/>
+          </a:xfrm>
+          <a:prstGeom prst="rect">
+            <a:avLst/>
+          </a:prstGeom>
+          <a:noFill/>
+          <a:ln/>
+        </p:spPr>
+        <p:txBody>
+          <a:bodyPr wrap="square" lIns="0" tIns="0" rIns="0" bIns="0" rtlCol="0" anchor="t"/>
+          <a:lstStyle/>
+          <a:p>
+            <a:pPr indent="0" marL="0">
+              <a:buNone/>
+            </a:pPr>
+            <a:r>
               <a:rPr lang="en-US" sz="1200" b="1" dirty="0">
                 <a:solidFill>
                   <a:srgbClr val="0E5A32"/>
@@ -14199,38 +13783,22 @@
                 <a:ea typeface="Calibri" pitchFamily="34" charset="-122"/>
                 <a:cs typeface="Calibri" pitchFamily="34" charset="-120"/>
               </a:rPr>
-              <a:t>Grundfos NB 65-160/157 curves (fit to maker data)</a:t>
+              <a:t>How flow is inferred</a:t>
             </a:r>
             <a:endParaRPr lang="en-US" sz="1200" dirty="0"/>
           </a:p>
         </p:txBody>
       </p:sp>
-      <p:graphicFrame>
-        <p:nvGraphicFramePr>
-          <p:cNvPr id="33" name="Chart 0" descr=""/>
-          <p:cNvGraphicFramePr/>
-          <p:nvPr/>
-        </p:nvGraphicFramePr>
-        <p:xfrm>
-          <a:off x="594360" y="3886200"/>
-          <a:ext cx="5897880" cy="2148840"/>
-        </p:xfrm>
-        <a:graphic xmlns:a="http://schemas.openxmlformats.org/drawingml/2006/main">
-          <a:graphicData uri="http://schemas.openxmlformats.org/drawingml/2006/chart">
-            <c:chart xmlns:c="http://schemas.openxmlformats.org/drawingml/2006/chart" r:id="rId1"/>
-          </a:graphicData>
-        </a:graphic>
-      </p:graphicFrame>
-      <p:sp>
-        <p:nvSpPr>
-          <p:cNvPr id="34" name="Text 31"/>
-          <p:cNvSpPr txBox="1"/>
-          <p:nvPr/>
-        </p:nvSpPr>
-        <p:spPr>
-          <a:xfrm>
-            <a:off x="658368" y="5989320"/>
-            <a:ext cx="5760720" cy="292608"/>
+      <p:sp>
+        <p:nvSpPr>
+          <p:cNvPr id="37" name="Text 34"/>
+          <p:cNvSpPr txBox="1"/>
+          <p:nvPr/>
+        </p:nvSpPr>
+        <p:spPr>
+          <a:xfrm>
+            <a:off x="4389120" y="3950208"/>
+            <a:ext cx="2084832" cy="2331720"/>
           </a:xfrm>
           <a:prstGeom prst="rect">
             <a:avLst/>
@@ -14242,27 +13810,115 @@
           <a:bodyPr wrap="square" lIns="0" tIns="0" rIns="0" bIns="0" rtlCol="0" anchor="t"/>
           <a:lstStyle/>
           <a:p>
-            <a:pPr indent="0" marL="0">
-              <a:buNone/>
-            </a:pPr>
-            <a:r>
-              <a:rPr lang="en-US" sz="950" i="1" dirty="0">
-                <a:solidFill>
-                  <a:srgbClr val="55655D"/>
-                </a:solidFill>
-                <a:latin typeface="Calibri" pitchFamily="34" charset="0"/>
-                <a:ea typeface="Calibri" pitchFamily="34" charset="-122"/>
-                <a:cs typeface="Calibri" pitchFamily="34" charset="-120"/>
-              </a:rPr>
-              <a:t>At an off-peak 61.6 m³/h the throttled pump delivers 31.7 m; the pipe needs 15.4 m. The gap is priced in ₹. Simulated; system curve assumed.</a:t>
-            </a:r>
-            <a:endParaRPr lang="en-US" sz="950" dirty="0"/>
-          </a:p>
-        </p:txBody>
-      </p:sp>
-      <p:sp>
-        <p:nvSpPr>
-          <p:cNvPr id="35" name="Shape 32"/>
+            <a:pPr marL="342900" indent="-342900">
+              <a:spcAft>
+                <a:spcPts val="300"/>
+              </a:spcAft>
+              <a:buSzPct val="100000"/>
+              <a:buChar char="•"/>
+            </a:pPr>
+            <a:r>
+              <a:rPr lang="en-US" sz="1050" dirty="0">
+                <a:solidFill>
+                  <a:srgbClr val="16261F"/>
+                </a:solidFill>
+                <a:latin typeface="Calibri" pitchFamily="34" charset="0"/>
+                <a:ea typeface="Calibri" pitchFamily="34" charset="-122"/>
+                <a:cs typeface="Calibri" pitchFamily="34" charset="-120"/>
+              </a:rPr>
+              <a:t>Head → flow from the pump curve H(Q)</a:t>
+            </a:r>
+            <a:endParaRPr lang="en-US" sz="1050" dirty="0"/>
+          </a:p>
+          <a:p>
+            <a:pPr marL="342900" indent="-342900">
+              <a:spcAft>
+                <a:spcPts val="300"/>
+              </a:spcAft>
+              <a:buSzPct val="100000"/>
+              <a:buChar char="•"/>
+            </a:pPr>
+            <a:r>
+              <a:rPr lang="en-US" sz="1050" dirty="0">
+                <a:solidFill>
+                  <a:srgbClr val="16261F"/>
+                </a:solidFill>
+                <a:latin typeface="Calibri" pitchFamily="34" charset="0"/>
+                <a:ea typeface="Calibri" pitchFamily="34" charset="-122"/>
+                <a:cs typeface="Calibri" pitchFamily="34" charset="-120"/>
+              </a:rPr>
+              <a:t>Power → shaft power via motor efficiency → flow</a:t>
+            </a:r>
+            <a:endParaRPr lang="en-US" sz="1050" dirty="0"/>
+          </a:p>
+          <a:p>
+            <a:pPr marL="342900" indent="-342900">
+              <a:spcAft>
+                <a:spcPts val="300"/>
+              </a:spcAft>
+              <a:buSzPct val="100000"/>
+              <a:buChar char="•"/>
+            </a:pPr>
+            <a:r>
+              <a:rPr lang="en-US" sz="1050" dirty="0">
+                <a:solidFill>
+                  <a:srgbClr val="16261F"/>
+                </a:solidFill>
+                <a:latin typeface="Calibri" pitchFamily="34" charset="0"/>
+                <a:ea typeface="Calibri" pitchFamily="34" charset="-122"/>
+                <a:cs typeface="Calibri" pitchFamily="34" charset="-120"/>
+              </a:rPr>
+              <a:t>Two scales, s_h and s_p, fitted from 7–14 days of logs</a:t>
+            </a:r>
+            <a:endParaRPr lang="en-US" sz="1050" dirty="0"/>
+          </a:p>
+          <a:p>
+            <a:pPr marL="342900" indent="-342900">
+              <a:spcAft>
+                <a:spcPts val="300"/>
+              </a:spcAft>
+              <a:buSzPct val="100000"/>
+              <a:buChar char="•"/>
+            </a:pPr>
+            <a:r>
+              <a:rPr lang="en-US" sz="1050" dirty="0">
+                <a:solidFill>
+                  <a:srgbClr val="16261F"/>
+                </a:solidFill>
+                <a:latin typeface="Calibri" pitchFamily="34" charset="0"/>
+                <a:ea typeface="Calibri" pitchFamily="34" charset="-122"/>
+                <a:cs typeface="Calibri" pitchFamily="34" charset="-120"/>
+              </a:rPr>
+              <a:t>Optional anchors: shut-off head, closed-valve power</a:t>
+            </a:r>
+            <a:endParaRPr lang="en-US" sz="1050" dirty="0"/>
+          </a:p>
+          <a:p>
+            <a:pPr marL="342900" indent="-342900">
+              <a:spcAft>
+                <a:spcPts val="300"/>
+              </a:spcAft>
+              <a:buSzPct val="100000"/>
+              <a:buChar char="•"/>
+            </a:pPr>
+            <a:r>
+              <a:rPr lang="en-US" sz="1050" dirty="0">
+                <a:solidFill>
+                  <a:srgbClr val="16261F"/>
+                </a:solidFill>
+                <a:latin typeface="Calibri" pitchFamily="34" charset="0"/>
+                <a:ea typeface="Calibri" pitchFamily="34" charset="-122"/>
+                <a:cs typeface="Calibri" pitchFamily="34" charset="-120"/>
+              </a:rPr>
+              <a:t>No flow meter used</a:t>
+            </a:r>
+            <a:endParaRPr lang="en-US" sz="1050" dirty="0"/>
+          </a:p>
+        </p:txBody>
+      </p:sp>
+      <p:sp>
+        <p:nvSpPr>
+          <p:cNvPr id="38" name="Shape 35"/>
           <p:cNvSpPr/>
           <p:nvPr/>
         </p:nvSpPr>
@@ -14289,7 +13945,7 @@
       </p:sp>
       <p:sp>
         <p:nvSpPr>
-          <p:cNvPr id="36" name="Shape 33"/>
+          <p:cNvPr id="39" name="Shape 36"/>
           <p:cNvSpPr/>
           <p:nvPr/>
         </p:nvSpPr>
@@ -14314,7 +13970,7 @@
       </p:sp>
       <p:sp>
         <p:nvSpPr>
-          <p:cNvPr id="37" name="Shape 34"/>
+          <p:cNvPr id="40" name="Shape 37"/>
           <p:cNvSpPr/>
           <p:nvPr/>
         </p:nvSpPr>
@@ -14339,7 +13995,7 @@
       </p:sp>
       <p:sp>
         <p:nvSpPr>
-          <p:cNvPr id="38" name="Shape 35"/>
+          <p:cNvPr id="41" name="Shape 38"/>
           <p:cNvSpPr/>
           <p:nvPr/>
         </p:nvSpPr>
@@ -14364,7 +14020,7 @@
       </p:sp>
       <p:sp>
         <p:nvSpPr>
-          <p:cNvPr id="39" name="Shape 36"/>
+          <p:cNvPr id="42" name="Shape 39"/>
           <p:cNvSpPr/>
           <p:nvPr/>
         </p:nvSpPr>
@@ -14389,7 +14045,7 @@
       </p:sp>
       <p:sp>
         <p:nvSpPr>
-          <p:cNvPr id="40" name="Shape 37"/>
+          <p:cNvPr id="43" name="Shape 40"/>
           <p:cNvSpPr/>
           <p:nvPr/>
         </p:nvSpPr>
@@ -14416,7 +14072,7 @@
       </p:sp>
       <p:sp>
         <p:nvSpPr>
-          <p:cNvPr id="41" name="Text 38"/>
+          <p:cNvPr id="44" name="Text 41"/>
           <p:cNvSpPr txBox="1"/>
           <p:nvPr/>
         </p:nvSpPr>
@@ -14455,7 +14111,7 @@
       </p:sp>
       <p:pic>
         <p:nvPicPr>
-          <p:cNvPr id="42" name="Image 0" descr="preencoded.png">    </p:cNvPr>
+          <p:cNvPr id="45" name="Image 1" descr="preencoded.png">    </p:cNvPr>
           <p:cNvPicPr>
             <a:picLocks noChangeAspect="1"/>
           </p:cNvPicPr>
@@ -14479,7 +14135,7 @@
       </p:pic>
       <p:sp>
         <p:nvSpPr>
-          <p:cNvPr id="43" name="Shape 39"/>
+          <p:cNvPr id="46" name="Shape 42"/>
           <p:cNvSpPr/>
           <p:nvPr/>
         </p:nvSpPr>
@@ -14506,7 +14162,7 @@
       </p:sp>
       <p:sp>
         <p:nvSpPr>
-          <p:cNvPr id="44" name="Shape 40"/>
+          <p:cNvPr id="47" name="Shape 43"/>
           <p:cNvSpPr/>
           <p:nvPr/>
         </p:nvSpPr>
@@ -14531,7 +14187,7 @@
       </p:sp>
       <p:sp>
         <p:nvSpPr>
-          <p:cNvPr id="45" name="Text 41"/>
+          <p:cNvPr id="48" name="Text 44"/>
           <p:cNvSpPr txBox="1"/>
           <p:nvPr/>
         </p:nvSpPr>
@@ -14570,7 +14226,7 @@
       </p:sp>
       <p:sp>
         <p:nvSpPr>
-          <p:cNvPr id="46" name="Shape 42"/>
+          <p:cNvPr id="49" name="Shape 45"/>
           <p:cNvSpPr/>
           <p:nvPr/>
         </p:nvSpPr>
@@ -14597,7 +14253,7 @@
       </p:sp>
       <p:sp>
         <p:nvSpPr>
-          <p:cNvPr id="47" name="Shape 43"/>
+          <p:cNvPr id="50" name="Shape 46"/>
           <p:cNvSpPr/>
           <p:nvPr/>
         </p:nvSpPr>
@@ -14622,7 +14278,7 @@
       </p:sp>
       <p:sp>
         <p:nvSpPr>
-          <p:cNvPr id="48" name="Text 44"/>
+          <p:cNvPr id="51" name="Text 47"/>
           <p:cNvSpPr txBox="1"/>
           <p:nvPr/>
         </p:nvSpPr>
@@ -14661,7 +14317,7 @@
       </p:sp>
       <p:sp>
         <p:nvSpPr>
-          <p:cNvPr id="49" name="Shape 45"/>
+          <p:cNvPr id="52" name="Shape 48"/>
           <p:cNvSpPr/>
           <p:nvPr/>
         </p:nvSpPr>
@@ -14688,7 +14344,7 @@
       </p:sp>
       <p:sp>
         <p:nvSpPr>
-          <p:cNvPr id="50" name="Shape 46"/>
+          <p:cNvPr id="53" name="Shape 49"/>
           <p:cNvSpPr/>
           <p:nvPr/>
         </p:nvSpPr>
@@ -14713,7 +14369,7 @@
       </p:sp>
       <p:sp>
         <p:nvSpPr>
-          <p:cNvPr id="51" name="Text 47"/>
+          <p:cNvPr id="54" name="Text 50"/>
           <p:cNvSpPr txBox="1"/>
           <p:nvPr/>
         </p:nvSpPr>
@@ -14752,7 +14408,7 @@
       </p:sp>
       <p:sp>
         <p:nvSpPr>
-          <p:cNvPr id="52" name="Shape 48"/>
+          <p:cNvPr id="55" name="Shape 51"/>
           <p:cNvSpPr/>
           <p:nvPr/>
         </p:nvSpPr>
@@ -14779,7 +14435,7 @@
       </p:sp>
       <p:sp>
         <p:nvSpPr>
-          <p:cNvPr id="53" name="Text 49"/>
+          <p:cNvPr id="56" name="Text 52"/>
           <p:cNvSpPr txBox="1"/>
           <p:nvPr/>
         </p:nvSpPr>
@@ -14818,7 +14474,7 @@
       </p:sp>
       <p:sp>
         <p:nvSpPr>
-          <p:cNvPr id="54" name="Shape 50"/>
+          <p:cNvPr id="57" name="Shape 53"/>
           <p:cNvSpPr/>
           <p:nvPr/>
         </p:nvSpPr>
@@ -14843,7 +14499,7 @@
       </p:sp>
       <p:sp>
         <p:nvSpPr>
-          <p:cNvPr id="55" name="Text 51"/>
+          <p:cNvPr id="58" name="Text 54"/>
           <p:cNvSpPr txBox="1"/>
           <p:nvPr/>
         </p:nvSpPr>
@@ -14882,7 +14538,7 @@
       </p:sp>
       <p:sp>
         <p:nvSpPr>
-          <p:cNvPr id="56" name="Text 52"/>
+          <p:cNvPr id="59" name="Text 55"/>
           <p:cNvSpPr txBox="1"/>
           <p:nvPr/>
         </p:nvSpPr>
@@ -14921,7 +14577,7 @@
       </p:sp>
       <p:sp>
         <p:nvSpPr>
-          <p:cNvPr id="57" name="Shape 53"/>
+          <p:cNvPr id="60" name="Shape 56"/>
           <p:cNvSpPr/>
           <p:nvPr/>
         </p:nvSpPr>
@@ -14946,7 +14602,7 @@
       </p:sp>
       <p:sp>
         <p:nvSpPr>
-          <p:cNvPr id="58" name="Text 54"/>
+          <p:cNvPr id="61" name="Text 57"/>
           <p:cNvSpPr txBox="1"/>
           <p:nvPr/>
         </p:nvSpPr>
@@ -14985,7 +14641,7 @@
       </p:sp>
       <p:sp>
         <p:nvSpPr>
-          <p:cNvPr id="59" name="Text 55"/>
+          <p:cNvPr id="62" name="Text 58"/>
           <p:cNvSpPr txBox="1"/>
           <p:nvPr/>
         </p:nvSpPr>
@@ -15024,7 +14680,7 @@
       </p:sp>
       <p:sp>
         <p:nvSpPr>
-          <p:cNvPr id="60" name="Shape 56"/>
+          <p:cNvPr id="63" name="Shape 59"/>
           <p:cNvSpPr/>
           <p:nvPr/>
         </p:nvSpPr>
@@ -15049,7 +14705,7 @@
       </p:sp>
       <p:sp>
         <p:nvSpPr>
-          <p:cNvPr id="61" name="Text 57"/>
+          <p:cNvPr id="64" name="Text 60"/>
           <p:cNvSpPr txBox="1"/>
           <p:nvPr/>
         </p:nvSpPr>
@@ -15088,7 +14744,7 @@
       </p:sp>
       <p:sp>
         <p:nvSpPr>
-          <p:cNvPr id="62" name="Text 58"/>
+          <p:cNvPr id="65" name="Text 61"/>
           <p:cNvSpPr txBox="1"/>
           <p:nvPr/>
         </p:nvSpPr>
@@ -15127,7 +14783,7 @@
       </p:sp>
       <p:sp>
         <p:nvSpPr>
-          <p:cNvPr id="63" name="Text 59"/>
+          <p:cNvPr id="66" name="Text 62"/>
           <p:cNvSpPr txBox="1"/>
           <p:nvPr/>
         </p:nvSpPr>

</xml_diff>

<commit_message>
Deck: remove QR from slide 5 (keep text link)
Co-Authored-By: Claude Sonnet 5.5 <noreply@anthropic.com>
Claude-Session: https://claude.ai/code/session_01DSH8N9v9LfqAPNyYnC9CEU
</commit_message>
<xml_diff>
--- a/yuva_yodha/submission/PumpRupee_ANS_4X_Yuva_Yodha_Application.pptx
+++ b/yuva_yodha/submission/PumpRupee_ANS_4X_Yuva_Yodha_Application.pptx
@@ -13005,40 +13005,16 @@
           </a:p>
         </p:txBody>
       </p:sp>
-      <p:pic>
-        <p:nvPicPr>
-          <p:cNvPr id="37" name="Image 7" descr="preencoded.png">    </p:cNvPr>
-          <p:cNvPicPr>
-            <a:picLocks noChangeAspect="1"/>
-          </p:cNvPicPr>
-          <p:nvPr/>
-        </p:nvPicPr>
-        <p:blipFill>
-          <a:blip r:embed="rId8"/>
-          <a:stretch>
-            <a:fillRect/>
-          </a:stretch>
-        </p:blipFill>
-        <p:spPr>
-          <a:xfrm>
-            <a:off x="548640" y="5669280"/>
-            <a:ext cx="658368" cy="658368"/>
-          </a:xfrm>
-          <a:prstGeom prst="rect">
-            <a:avLst/>
-          </a:prstGeom>
-        </p:spPr>
-      </p:pic>
-      <p:sp>
-        <p:nvSpPr>
-          <p:cNvPr id="38" name="Text 28"/>
-          <p:cNvSpPr txBox="1"/>
-          <p:nvPr/>
-        </p:nvSpPr>
-        <p:spPr>
-          <a:xfrm>
-            <a:off x="1344168" y="5742432"/>
-            <a:ext cx="3840480" cy="658368"/>
+      <p:sp>
+        <p:nvSpPr>
+          <p:cNvPr id="37" name="Text 28"/>
+          <p:cNvSpPr txBox="1"/>
+          <p:nvPr/>
+        </p:nvSpPr>
+        <p:spPr>
+          <a:xfrm>
+            <a:off x="548640" y="5715000"/>
+            <a:ext cx="4389120" cy="640080"/>
           </a:xfrm>
           <a:prstGeom prst="rect">
             <a:avLst/>
@@ -13078,7 +13054,7 @@
                 <a:latin typeface="Calibri" pitchFamily="34" charset="0"/>
                 <a:ea typeface="Calibri" pitchFamily="34" charset="-122"/>
                 <a:cs typeface="Calibri" pitchFamily="34" charset="-120"/>
-                <a:hlinkClick r:id="rId9" invalidUrl="" action="" tgtFrame="" tooltip="" history="1" highlightClick="0" endSnd="0">
+                <a:hlinkClick r:id="rId8" invalidUrl="" action="" tgtFrame="" tooltip="" history="1" highlightClick="0" endSnd="0">
                   <a:extLst>
                     <a:ext uri="{A12FA001-AC4F-418D-AE19-62706E023703}">
                       <ahyp:hlinkClr xmlns:ahyp="http://schemas.microsoft.com/office/drawing/2018/hyperlinkcolor" val="tx"/>
@@ -13103,7 +13079,7 @@
                 <a:ea typeface="Calibri" pitchFamily="34" charset="-122"/>
                 <a:cs typeface="Calibri" pitchFamily="34" charset="-120"/>
               </a:rPr>
-              <a:t>Simulated data · scan the QR code</a:t>
+              <a:t>Simulated data</a:t>
             </a:r>
             <a:endParaRPr lang="en-US" sz="1300" dirty="0"/>
           </a:p>
@@ -13111,7 +13087,7 @@
       </p:sp>
       <p:sp>
         <p:nvSpPr>
-          <p:cNvPr id="39" name="Shape 29"/>
+          <p:cNvPr id="38" name="Shape 29"/>
           <p:cNvSpPr/>
           <p:nvPr/>
         </p:nvSpPr>
@@ -13138,7 +13114,7 @@
       </p:sp>
       <p:sp>
         <p:nvSpPr>
-          <p:cNvPr id="40" name="Shape 30"/>
+          <p:cNvPr id="39" name="Shape 30"/>
           <p:cNvSpPr/>
           <p:nvPr/>
         </p:nvSpPr>
@@ -13163,7 +13139,7 @@
       </p:sp>
       <p:sp>
         <p:nvSpPr>
-          <p:cNvPr id="41" name="Shape 31"/>
+          <p:cNvPr id="40" name="Shape 31"/>
           <p:cNvSpPr/>
           <p:nvPr/>
         </p:nvSpPr>
@@ -13188,7 +13164,7 @@
       </p:sp>
       <p:sp>
         <p:nvSpPr>
-          <p:cNvPr id="42" name="Shape 32"/>
+          <p:cNvPr id="41" name="Shape 32"/>
           <p:cNvSpPr/>
           <p:nvPr/>
         </p:nvSpPr>
@@ -13213,7 +13189,7 @@
       </p:sp>
       <p:sp>
         <p:nvSpPr>
-          <p:cNvPr id="43" name="Shape 33"/>
+          <p:cNvPr id="42" name="Shape 33"/>
           <p:cNvSpPr/>
           <p:nvPr/>
         </p:nvSpPr>
@@ -13238,7 +13214,7 @@
       </p:sp>
       <p:sp>
         <p:nvSpPr>
-          <p:cNvPr id="44" name="Shape 34"/>
+          <p:cNvPr id="43" name="Shape 34"/>
           <p:cNvSpPr/>
           <p:nvPr/>
         </p:nvSpPr>
@@ -13265,7 +13241,7 @@
       </p:sp>
       <p:sp>
         <p:nvSpPr>
-          <p:cNvPr id="45" name="Text 35"/>
+          <p:cNvPr id="44" name="Text 35"/>
           <p:cNvSpPr txBox="1"/>
           <p:nvPr/>
         </p:nvSpPr>
@@ -13304,14 +13280,14 @@
       </p:sp>
       <p:pic>
         <p:nvPicPr>
-          <p:cNvPr id="46" name="Image 8" descr="preencoded.png">    </p:cNvPr>
+          <p:cNvPr id="45" name="Image 7" descr="preencoded.png">    </p:cNvPr>
           <p:cNvPicPr>
             <a:picLocks noChangeAspect="1"/>
           </p:cNvPicPr>
           <p:nvPr/>
         </p:nvPicPr>
         <p:blipFill>
-          <a:blip r:embed="rId10"/>
+          <a:blip r:embed="rId9"/>
           <a:stretch>
             <a:fillRect/>
           </a:stretch>
@@ -13328,7 +13304,7 @@
       </p:pic>
       <p:sp>
         <p:nvSpPr>
-          <p:cNvPr id="47" name="Shape 36"/>
+          <p:cNvPr id="46" name="Shape 36"/>
           <p:cNvSpPr/>
           <p:nvPr/>
         </p:nvSpPr>
@@ -13355,7 +13331,7 @@
       </p:sp>
       <p:sp>
         <p:nvSpPr>
-          <p:cNvPr id="48" name="Shape 37"/>
+          <p:cNvPr id="47" name="Shape 37"/>
           <p:cNvSpPr/>
           <p:nvPr/>
         </p:nvSpPr>
@@ -13380,7 +13356,7 @@
       </p:sp>
       <p:sp>
         <p:nvSpPr>
-          <p:cNvPr id="49" name="Text 38"/>
+          <p:cNvPr id="48" name="Text 38"/>
           <p:cNvSpPr txBox="1"/>
           <p:nvPr/>
         </p:nvSpPr>
@@ -13419,7 +13395,7 @@
       </p:sp>
       <p:sp>
         <p:nvSpPr>
-          <p:cNvPr id="50" name="Shape 39"/>
+          <p:cNvPr id="49" name="Shape 39"/>
           <p:cNvSpPr/>
           <p:nvPr/>
         </p:nvSpPr>
@@ -13446,7 +13422,7 @@
       </p:sp>
       <p:sp>
         <p:nvSpPr>
-          <p:cNvPr id="51" name="Shape 40"/>
+          <p:cNvPr id="50" name="Shape 40"/>
           <p:cNvSpPr/>
           <p:nvPr/>
         </p:nvSpPr>
@@ -13471,7 +13447,7 @@
       </p:sp>
       <p:sp>
         <p:nvSpPr>
-          <p:cNvPr id="52" name="Text 41"/>
+          <p:cNvPr id="51" name="Text 41"/>
           <p:cNvSpPr txBox="1"/>
           <p:nvPr/>
         </p:nvSpPr>
@@ -13510,7 +13486,7 @@
       </p:sp>
       <p:sp>
         <p:nvSpPr>
-          <p:cNvPr id="53" name="Shape 42"/>
+          <p:cNvPr id="52" name="Shape 42"/>
           <p:cNvSpPr/>
           <p:nvPr/>
         </p:nvSpPr>
@@ -13537,7 +13513,7 @@
       </p:sp>
       <p:sp>
         <p:nvSpPr>
-          <p:cNvPr id="54" name="Shape 43"/>
+          <p:cNvPr id="53" name="Shape 43"/>
           <p:cNvSpPr/>
           <p:nvPr/>
         </p:nvSpPr>
@@ -13562,7 +13538,7 @@
       </p:sp>
       <p:sp>
         <p:nvSpPr>
-          <p:cNvPr id="55" name="Text 44"/>
+          <p:cNvPr id="54" name="Text 44"/>
           <p:cNvSpPr txBox="1"/>
           <p:nvPr/>
         </p:nvSpPr>
@@ -13601,7 +13577,7 @@
       </p:sp>
       <p:sp>
         <p:nvSpPr>
-          <p:cNvPr id="56" name="Shape 45"/>
+          <p:cNvPr id="55" name="Shape 45"/>
           <p:cNvSpPr/>
           <p:nvPr/>
         </p:nvSpPr>
@@ -13628,7 +13604,7 @@
       </p:sp>
       <p:sp>
         <p:nvSpPr>
-          <p:cNvPr id="57" name="Text 46"/>
+          <p:cNvPr id="56" name="Text 46"/>
           <p:cNvSpPr txBox="1"/>
           <p:nvPr/>
         </p:nvSpPr>
@@ -13667,7 +13643,7 @@
       </p:sp>
       <p:sp>
         <p:nvSpPr>
-          <p:cNvPr id="58" name="Shape 47"/>
+          <p:cNvPr id="57" name="Shape 47"/>
           <p:cNvSpPr/>
           <p:nvPr/>
         </p:nvSpPr>
@@ -13692,7 +13668,7 @@
       </p:sp>
       <p:sp>
         <p:nvSpPr>
-          <p:cNvPr id="59" name="Text 48"/>
+          <p:cNvPr id="58" name="Text 48"/>
           <p:cNvSpPr txBox="1"/>
           <p:nvPr/>
         </p:nvSpPr>
@@ -13731,7 +13707,7 @@
       </p:sp>
       <p:sp>
         <p:nvSpPr>
-          <p:cNvPr id="60" name="Text 49"/>
+          <p:cNvPr id="59" name="Text 49"/>
           <p:cNvSpPr txBox="1"/>
           <p:nvPr/>
         </p:nvSpPr>
@@ -13770,7 +13746,7 @@
       </p:sp>
       <p:sp>
         <p:nvSpPr>
-          <p:cNvPr id="61" name="Shape 50"/>
+          <p:cNvPr id="60" name="Shape 50"/>
           <p:cNvSpPr/>
           <p:nvPr/>
         </p:nvSpPr>
@@ -13795,7 +13771,7 @@
       </p:sp>
       <p:sp>
         <p:nvSpPr>
-          <p:cNvPr id="62" name="Text 51"/>
+          <p:cNvPr id="61" name="Text 51"/>
           <p:cNvSpPr txBox="1"/>
           <p:nvPr/>
         </p:nvSpPr>
@@ -13834,7 +13810,7 @@
       </p:sp>
       <p:sp>
         <p:nvSpPr>
-          <p:cNvPr id="63" name="Text 52"/>
+          <p:cNvPr id="62" name="Text 52"/>
           <p:cNvSpPr txBox="1"/>
           <p:nvPr/>
         </p:nvSpPr>
@@ -13873,7 +13849,7 @@
       </p:sp>
       <p:sp>
         <p:nvSpPr>
-          <p:cNvPr id="64" name="Shape 53"/>
+          <p:cNvPr id="63" name="Shape 53"/>
           <p:cNvSpPr/>
           <p:nvPr/>
         </p:nvSpPr>
@@ -13898,7 +13874,7 @@
       </p:sp>
       <p:sp>
         <p:nvSpPr>
-          <p:cNvPr id="65" name="Text 54"/>
+          <p:cNvPr id="64" name="Text 54"/>
           <p:cNvSpPr txBox="1"/>
           <p:nvPr/>
         </p:nvSpPr>
@@ -13937,7 +13913,7 @@
       </p:sp>
       <p:sp>
         <p:nvSpPr>
-          <p:cNvPr id="66" name="Text 55"/>
+          <p:cNvPr id="65" name="Text 55"/>
           <p:cNvSpPr txBox="1"/>
           <p:nvPr/>
         </p:nvSpPr>
@@ -13976,7 +13952,7 @@
       </p:sp>
       <p:sp>
         <p:nvSpPr>
-          <p:cNvPr id="67" name="Shape 56"/>
+          <p:cNvPr id="66" name="Shape 56"/>
           <p:cNvSpPr/>
           <p:nvPr/>
         </p:nvSpPr>
@@ -14003,7 +13979,7 @@
       </p:sp>
       <p:sp>
         <p:nvSpPr>
-          <p:cNvPr id="68" name="Text 57"/>
+          <p:cNvPr id="67" name="Text 57"/>
           <p:cNvSpPr txBox="1"/>
           <p:nvPr/>
         </p:nvSpPr>

</xml_diff>